<commit_message>
Add full project documentation and a Deployment slide
- DOCUMENTATION.md: end-to-end explanation of the system (architecture,
  workflow engine, data model, RBAC, SAP integration, notifications,
  security, background engines, deployment, how to run).
- Presentation: add a '09 - DEPLOYMENT' slide (live URL, single-service
  architecture, managed Postgres + TLS, production hardening, real email
  delivery) and a matching agenda entry.
</commit_message>
<xml_diff>
--- a/CCMS-Presentation.pptx
+++ b/CCMS-Presentation.pptx
@@ -23,6 +23,7 @@
     <p:sldId id="272" r:id="rId23"/>
     <p:sldId id="273" r:id="rId24"/>
     <p:sldId id="274" r:id="rId25"/>
+    <p:sldId id="275" r:id="rId26"/>
     <p:sldId id="271" r:id="rId22"/>
   </p:sldIdLst>
   <p:sldSz cx="12191695" cy="6858000" type="screen4x3"/>
@@ -22898,6 +22899,1472 @@
                 <a:latin typeface="Segoe UI"/>
               </a:rPr>
               <a:t>How every stakeholder stays informed</a:t>
+            </a:r>
+          </a:p>
+        </p:txBody>
+      </p:sp>
+      <p:sp>
+        <p:nvSpPr>
+          <p:cNvPr id="49" name="Rounded Rectangle 48"/>
+          <p:cNvSpPr/>
+          <p:nvPr/>
+        </p:nvSpPr>
+        <p:spPr>
+          <a:xfrm>
+            <a:off x="3337560" y="4590288"/>
+            <a:ext cx="5486400" cy="658368"/>
+          </a:xfrm>
+          <a:prstGeom prst="roundRect">
+            <a:avLst>
+              <a:gd name="adj" fmla="val 10000"/>
+            </a:avLst>
+          </a:prstGeom>
+          <a:solidFill>
+            <a:srgbClr val="FFFFFF"/>
+          </a:solidFill>
+          <a:ln w="12700">
+            <a:solidFill>
+              <a:srgbClr val="D5DDE3"/>
+            </a:solidFill>
+          </a:ln>
+          <a:effectLst/>
+        </p:spPr>
+        <p:style>
+          <a:lnRef idx="1">
+            <a:schemeClr val="accent1"/>
+          </a:lnRef>
+          <a:fillRef idx="3">
+            <a:schemeClr val="accent1"/>
+          </a:fillRef>
+          <a:effectRef idx="2">
+            <a:schemeClr val="accent1"/>
+          </a:effectRef>
+          <a:fontRef idx="minor">
+            <a:schemeClr val="lt1"/>
+          </a:fontRef>
+        </p:style>
+        <p:txBody>
+          <a:bodyPr rtlCol="0" anchor="ctr"/>
+          <a:lstStyle/>
+          <a:p>
+            <a:pPr algn="ctr"/>
+          </a:p>
+        </p:txBody>
+      </p:sp>
+      <p:sp>
+        <p:nvSpPr>
+          <p:cNvPr id="50" name="Rounded Rectangle 49"/>
+          <p:cNvSpPr/>
+          <p:nvPr/>
+        </p:nvSpPr>
+        <p:spPr>
+          <a:xfrm>
+            <a:off x="3337560" y="4590288"/>
+            <a:ext cx="822960" cy="658368"/>
+          </a:xfrm>
+          <a:prstGeom prst="roundRect">
+            <a:avLst>
+              <a:gd name="adj" fmla="val 10000"/>
+            </a:avLst>
+          </a:prstGeom>
+          <a:solidFill>
+            <a:srgbClr val="112A40"/>
+          </a:solidFill>
+          <a:ln>
+            <a:noFill/>
+          </a:ln>
+          <a:effectLst/>
+        </p:spPr>
+        <p:style>
+          <a:lnRef idx="1">
+            <a:schemeClr val="accent1"/>
+          </a:lnRef>
+          <a:fillRef idx="3">
+            <a:schemeClr val="accent1"/>
+          </a:fillRef>
+          <a:effectRef idx="2">
+            <a:schemeClr val="accent1"/>
+          </a:effectRef>
+          <a:fontRef idx="minor">
+            <a:schemeClr val="lt1"/>
+          </a:fontRef>
+        </p:style>
+        <p:txBody>
+          <a:bodyPr rtlCol="0" anchor="ctr"/>
+          <a:lstStyle/>
+          <a:p>
+            <a:pPr algn="ctr"/>
+          </a:p>
+        </p:txBody>
+      </p:sp>
+      <p:sp>
+        <p:nvSpPr>
+          <p:cNvPr id="51" name="Rectangle 50"/>
+          <p:cNvSpPr/>
+          <p:nvPr/>
+        </p:nvSpPr>
+        <p:spPr>
+          <a:xfrm>
+            <a:off x="3749039" y="4590288"/>
+            <a:ext cx="411480" cy="658368"/>
+          </a:xfrm>
+          <a:prstGeom prst="rect">
+            <a:avLst/>
+          </a:prstGeom>
+          <a:solidFill>
+            <a:srgbClr val="112A40"/>
+          </a:solidFill>
+          <a:ln>
+            <a:noFill/>
+          </a:ln>
+          <a:effectLst/>
+        </p:spPr>
+        <p:style>
+          <a:lnRef idx="1">
+            <a:schemeClr val="accent1"/>
+          </a:lnRef>
+          <a:fillRef idx="3">
+            <a:schemeClr val="accent1"/>
+          </a:fillRef>
+          <a:effectRef idx="2">
+            <a:schemeClr val="accent1"/>
+          </a:effectRef>
+          <a:fontRef idx="minor">
+            <a:schemeClr val="lt1"/>
+          </a:fontRef>
+        </p:style>
+        <p:txBody>
+          <a:bodyPr rtlCol="0" anchor="ctr"/>
+          <a:lstStyle/>
+          <a:p>
+            <a:pPr algn="ctr"/>
+          </a:p>
+        </p:txBody>
+      </p:sp>
+      <p:sp>
+        <p:nvSpPr>
+          <p:cNvPr id="52" name="TextBox 51"/>
+          <p:cNvSpPr txBox="1"/>
+          <p:nvPr/>
+        </p:nvSpPr>
+        <p:spPr>
+          <a:xfrm>
+            <a:off x="3337560" y="4590288"/>
+            <a:ext cx="822960" cy="658368"/>
+          </a:xfrm>
+          <a:prstGeom prst="rect">
+            <a:avLst/>
+          </a:prstGeom>
+          <a:noFill/>
+        </p:spPr>
+        <p:txBody>
+          <a:bodyPr wrap="square" lIns="0" rIns="0" tIns="0" bIns="0" anchor="ctr">
+            <a:spAutoFit/>
+          </a:bodyPr>
+          <a:lstStyle/>
+          <a:p>
+            <a:pPr algn="ctr"/>
+            <a:r>
+              <a:rPr sz="1900" b="1">
+                <a:solidFill>
+                  <a:srgbClr val="E0912F"/>
+                </a:solidFill>
+                <a:latin typeface="Segoe UI Semibold"/>
+              </a:rPr>
+              <a:t>09</a:t>
+            </a:r>
+          </a:p>
+        </p:txBody>
+      </p:sp>
+      <p:sp>
+        <p:nvSpPr>
+          <p:cNvPr id="53" name="TextBox 52"/>
+          <p:cNvSpPr txBox="1"/>
+          <p:nvPr/>
+        </p:nvSpPr>
+        <p:spPr>
+          <a:xfrm>
+            <a:off x="4297680" y="4672583"/>
+            <a:ext cx="4389120" cy="512064"/>
+          </a:xfrm>
+          <a:prstGeom prst="rect">
+            <a:avLst/>
+          </a:prstGeom>
+          <a:noFill/>
+        </p:spPr>
+        <p:txBody>
+          <a:bodyPr wrap="square" lIns="0" rIns="0" tIns="0" bIns="0" anchor="t">
+            <a:spAutoFit/>
+          </a:bodyPr>
+          <a:lstStyle/>
+          <a:p>
+            <a:pPr algn="l"/>
+            <a:r>
+              <a:rPr sz="1400" b="1">
+                <a:solidFill>
+                  <a:srgbClr val="112A40"/>
+                </a:solidFill>
+                <a:latin typeface="Segoe UI Semibold"/>
+              </a:rPr>
+              <a:t>Deployment</a:t>
+            </a:r>
+          </a:p>
+          <a:p>
+            <a:pPr algn="l"/>
+            <a:r>
+              <a:rPr sz="1050" b="0">
+                <a:solidFill>
+                  <a:srgbClr val="5A6B78"/>
+                </a:solidFill>
+                <a:latin typeface="Segoe UI"/>
+              </a:rPr>
+              <a:t>Live, single-service, on managed Postgres</a:t>
+            </a:r>
+          </a:p>
+        </p:txBody>
+      </p:sp>
+    </p:spTree>
+  </p:cSld>
+  <p:clrMapOvr>
+    <a:masterClrMapping/>
+  </p:clrMapOvr>
+</p:sld>
+</file>
+
+<file path=ppt/slides/slide20.xml><?xml version="1.0" encoding="utf-8"?>
+<p:sld xmlns:a="http://schemas.openxmlformats.org/drawingml/2006/main" xmlns:p="http://schemas.openxmlformats.org/presentationml/2006/main" xmlns:r="http://schemas.openxmlformats.org/officeDocument/2006/relationships">
+  <p:cSld>
+    <p:spTree>
+      <p:nvGrpSpPr>
+        <p:cNvPr id="1" name=""/>
+        <p:cNvGrpSpPr/>
+        <p:nvPr/>
+      </p:nvGrpSpPr>
+      <p:grpSpPr/>
+      <p:sp>
+        <p:nvSpPr>
+          <p:cNvPr id="2" name="Rectangle 1"/>
+          <p:cNvSpPr/>
+          <p:nvPr/>
+        </p:nvSpPr>
+        <p:spPr>
+          <a:xfrm>
+            <a:off x="0" y="0"/>
+            <a:ext cx="12191695" cy="1170432"/>
+          </a:xfrm>
+          <a:prstGeom prst="rect">
+            <a:avLst/>
+          </a:prstGeom>
+          <a:solidFill>
+            <a:srgbClr val="112A40"/>
+          </a:solidFill>
+          <a:ln>
+            <a:noFill/>
+          </a:ln>
+          <a:effectLst/>
+        </p:spPr>
+        <p:style>
+          <a:lnRef idx="1">
+            <a:schemeClr val="accent1"/>
+          </a:lnRef>
+          <a:fillRef idx="3">
+            <a:schemeClr val="accent1"/>
+          </a:fillRef>
+          <a:effectRef idx="2">
+            <a:schemeClr val="accent1"/>
+          </a:effectRef>
+          <a:fontRef idx="minor">
+            <a:schemeClr val="lt1"/>
+          </a:fontRef>
+        </p:style>
+        <p:txBody>
+          <a:bodyPr rtlCol="0" anchor="ctr"/>
+          <a:lstStyle/>
+          <a:p>
+            <a:pPr algn="ctr"/>
+          </a:p>
+        </p:txBody>
+      </p:sp>
+      <p:sp>
+        <p:nvSpPr>
+          <p:cNvPr id="3" name="Rectangle 2"/>
+          <p:cNvSpPr/>
+          <p:nvPr/>
+        </p:nvSpPr>
+        <p:spPr>
+          <a:xfrm>
+            <a:off x="0" y="1170432"/>
+            <a:ext cx="12191695" cy="54864"/>
+          </a:xfrm>
+          <a:prstGeom prst="rect">
+            <a:avLst/>
+          </a:prstGeom>
+          <a:solidFill>
+            <a:srgbClr val="E0912F"/>
+          </a:solidFill>
+          <a:ln>
+            <a:noFill/>
+          </a:ln>
+          <a:effectLst/>
+        </p:spPr>
+        <p:style>
+          <a:lnRef idx="1">
+            <a:schemeClr val="accent1"/>
+          </a:lnRef>
+          <a:fillRef idx="3">
+            <a:schemeClr val="accent1"/>
+          </a:fillRef>
+          <a:effectRef idx="2">
+            <a:schemeClr val="accent1"/>
+          </a:effectRef>
+          <a:fontRef idx="minor">
+            <a:schemeClr val="lt1"/>
+          </a:fontRef>
+        </p:style>
+        <p:txBody>
+          <a:bodyPr rtlCol="0" anchor="ctr"/>
+          <a:lstStyle/>
+          <a:p>
+            <a:pPr algn="ctr"/>
+          </a:p>
+        </p:txBody>
+      </p:sp>
+      <p:sp>
+        <p:nvSpPr>
+          <p:cNvPr id="4" name="TextBox 3"/>
+          <p:cNvSpPr txBox="1"/>
+          <p:nvPr/>
+        </p:nvSpPr>
+        <p:spPr>
+          <a:xfrm>
+            <a:off x="502920" y="219456"/>
+            <a:ext cx="10058400" cy="274320"/>
+          </a:xfrm>
+          <a:prstGeom prst="rect">
+            <a:avLst/>
+          </a:prstGeom>
+          <a:noFill/>
+        </p:spPr>
+        <p:txBody>
+          <a:bodyPr wrap="square" lIns="0" rIns="0" tIns="0" bIns="0" anchor="t">
+            <a:spAutoFit/>
+          </a:bodyPr>
+          <a:lstStyle/>
+          <a:p>
+            <a:pPr algn="l"/>
+            <a:r>
+              <a:rPr sz="1100" b="1">
+                <a:solidFill>
+                  <a:srgbClr val="E0912F"/>
+                </a:solidFill>
+                <a:latin typeface="Segoe UI"/>
+              </a:rPr>
+              <a:t>09 · DEPLOYMENT</a:t>
+            </a:r>
+          </a:p>
+        </p:txBody>
+      </p:sp>
+      <p:sp>
+        <p:nvSpPr>
+          <p:cNvPr id="5" name="TextBox 4"/>
+          <p:cNvSpPr txBox="1"/>
+          <p:nvPr/>
+        </p:nvSpPr>
+        <p:spPr>
+          <a:xfrm>
+            <a:off x="502920" y="457200"/>
+            <a:ext cx="11155680" cy="640080"/>
+          </a:xfrm>
+          <a:prstGeom prst="rect">
+            <a:avLst/>
+          </a:prstGeom>
+          <a:noFill/>
+        </p:spPr>
+        <p:txBody>
+          <a:bodyPr wrap="square" lIns="0" rIns="0" tIns="0" bIns="0" anchor="t">
+            <a:spAutoFit/>
+          </a:bodyPr>
+          <a:lstStyle/>
+          <a:p>
+            <a:pPr algn="l"/>
+            <a:r>
+              <a:rPr sz="2600" b="1">
+                <a:solidFill>
+                  <a:srgbClr val="FFFFFF"/>
+                </a:solidFill>
+                <a:latin typeface="Segoe UI Semibold"/>
+              </a:rPr>
+              <a:t>Deployed live on the internet</a:t>
+            </a:r>
+          </a:p>
+        </p:txBody>
+      </p:sp>
+      <p:sp>
+        <p:nvSpPr>
+          <p:cNvPr id="6" name="Rectangle 5"/>
+          <p:cNvSpPr/>
+          <p:nvPr/>
+        </p:nvSpPr>
+        <p:spPr>
+          <a:xfrm>
+            <a:off x="0" y="6510528"/>
+            <a:ext cx="12191695" cy="347472"/>
+          </a:xfrm>
+          <a:prstGeom prst="rect">
+            <a:avLst/>
+          </a:prstGeom>
+          <a:solidFill>
+            <a:srgbClr val="112A40"/>
+          </a:solidFill>
+          <a:ln>
+            <a:noFill/>
+          </a:ln>
+          <a:effectLst/>
+        </p:spPr>
+        <p:style>
+          <a:lnRef idx="1">
+            <a:schemeClr val="accent1"/>
+          </a:lnRef>
+          <a:fillRef idx="3">
+            <a:schemeClr val="accent1"/>
+          </a:fillRef>
+          <a:effectRef idx="2">
+            <a:schemeClr val="accent1"/>
+          </a:effectRef>
+          <a:fontRef idx="minor">
+            <a:schemeClr val="lt1"/>
+          </a:fontRef>
+        </p:style>
+        <p:txBody>
+          <a:bodyPr rtlCol="0" anchor="ctr"/>
+          <a:lstStyle/>
+          <a:p>
+            <a:pPr algn="ctr"/>
+          </a:p>
+        </p:txBody>
+      </p:sp>
+      <p:sp>
+        <p:nvSpPr>
+          <p:cNvPr id="7" name="TextBox 6"/>
+          <p:cNvSpPr txBox="1"/>
+          <p:nvPr/>
+        </p:nvSpPr>
+        <p:spPr>
+          <a:xfrm>
+            <a:off x="502920" y="6528816"/>
+            <a:ext cx="7315200" cy="310896"/>
+          </a:xfrm>
+          <a:prstGeom prst="rect">
+            <a:avLst/>
+          </a:prstGeom>
+          <a:noFill/>
+        </p:spPr>
+        <p:txBody>
+          <a:bodyPr wrap="square" lIns="0" rIns="0" tIns="0" bIns="0" anchor="t">
+            <a:spAutoFit/>
+          </a:bodyPr>
+          <a:lstStyle/>
+          <a:p>
+            <a:pPr algn="l"/>
+            <a:r>
+              <a:rPr sz="900" b="0">
+                <a:solidFill>
+                  <a:srgbClr val="B9C7D2"/>
+                </a:solidFill>
+                <a:latin typeface="Segoe UI"/>
+              </a:rPr>
+              <a:t>Customer Complaint Management System  ·  Orient Paper &amp; Mill</a:t>
+            </a:r>
+          </a:p>
+        </p:txBody>
+      </p:sp>
+      <p:sp>
+        <p:nvSpPr>
+          <p:cNvPr id="8" name="TextBox 7"/>
+          <p:cNvSpPr txBox="1"/>
+          <p:nvPr/>
+        </p:nvSpPr>
+        <p:spPr>
+          <a:xfrm>
+            <a:off x="10424160" y="6528816"/>
+            <a:ext cx="1280160" cy="310896"/>
+          </a:xfrm>
+          <a:prstGeom prst="rect">
+            <a:avLst/>
+          </a:prstGeom>
+          <a:noFill/>
+        </p:spPr>
+        <p:txBody>
+          <a:bodyPr wrap="square" lIns="0" rIns="0" tIns="0" bIns="0" anchor="t">
+            <a:spAutoFit/>
+          </a:bodyPr>
+          <a:lstStyle/>
+          <a:p>
+            <a:pPr algn="r"/>
+            <a:r>
+              <a:rPr sz="900" b="1">
+                <a:solidFill>
+                  <a:srgbClr val="E0912F"/>
+                </a:solidFill>
+                <a:latin typeface="Segoe UI"/>
+              </a:rPr>
+              <a:t>18</a:t>
+            </a:r>
+          </a:p>
+        </p:txBody>
+      </p:sp>
+      <p:sp>
+        <p:nvSpPr>
+          <p:cNvPr id="9" name="Rounded Rectangle 8"/>
+          <p:cNvSpPr/>
+          <p:nvPr/>
+        </p:nvSpPr>
+        <p:spPr>
+          <a:xfrm>
+            <a:off x="502920" y="1463040"/>
+            <a:ext cx="11183112" cy="841248"/>
+          </a:xfrm>
+          <a:prstGeom prst="roundRect">
+            <a:avLst>
+              <a:gd name="adj" fmla="val 10000"/>
+            </a:avLst>
+          </a:prstGeom>
+          <a:solidFill>
+            <a:srgbClr val="EEF2F5"/>
+          </a:solidFill>
+          <a:ln>
+            <a:noFill/>
+          </a:ln>
+          <a:effectLst/>
+        </p:spPr>
+        <p:style>
+          <a:lnRef idx="1">
+            <a:schemeClr val="accent1"/>
+          </a:lnRef>
+          <a:fillRef idx="3">
+            <a:schemeClr val="accent1"/>
+          </a:fillRef>
+          <a:effectRef idx="2">
+            <a:schemeClr val="accent1"/>
+          </a:effectRef>
+          <a:fontRef idx="minor">
+            <a:schemeClr val="lt1"/>
+          </a:fontRef>
+        </p:style>
+        <p:txBody>
+          <a:bodyPr rtlCol="0" anchor="ctr"/>
+          <a:lstStyle/>
+          <a:p>
+            <a:pPr algn="ctr"/>
+          </a:p>
+        </p:txBody>
+      </p:sp>
+      <p:sp>
+        <p:nvSpPr>
+          <p:cNvPr id="10" name="Rounded Rectangle 9"/>
+          <p:cNvSpPr/>
+          <p:nvPr/>
+        </p:nvSpPr>
+        <p:spPr>
+          <a:xfrm>
+            <a:off x="713232" y="1609344"/>
+            <a:ext cx="118872" cy="548640"/>
+          </a:xfrm>
+          <a:prstGeom prst="roundRect">
+            <a:avLst>
+              <a:gd name="adj" fmla="val 50000"/>
+            </a:avLst>
+          </a:prstGeom>
+          <a:solidFill>
+            <a:srgbClr val="E0912F"/>
+          </a:solidFill>
+          <a:ln>
+            <a:noFill/>
+          </a:ln>
+          <a:effectLst/>
+        </p:spPr>
+        <p:style>
+          <a:lnRef idx="1">
+            <a:schemeClr val="accent1"/>
+          </a:lnRef>
+          <a:fillRef idx="3">
+            <a:schemeClr val="accent1"/>
+          </a:fillRef>
+          <a:effectRef idx="2">
+            <a:schemeClr val="accent1"/>
+          </a:effectRef>
+          <a:fontRef idx="minor">
+            <a:schemeClr val="lt1"/>
+          </a:fontRef>
+        </p:style>
+        <p:txBody>
+          <a:bodyPr rtlCol="0" anchor="ctr"/>
+          <a:lstStyle/>
+          <a:p>
+            <a:pPr algn="ctr"/>
+          </a:p>
+        </p:txBody>
+      </p:sp>
+      <p:sp>
+        <p:nvSpPr>
+          <p:cNvPr id="11" name="TextBox 10"/>
+          <p:cNvSpPr txBox="1"/>
+          <p:nvPr/>
+        </p:nvSpPr>
+        <p:spPr>
+          <a:xfrm>
+            <a:off x="969264" y="1463040"/>
+            <a:ext cx="10424160" cy="841248"/>
+          </a:xfrm>
+          <a:prstGeom prst="rect">
+            <a:avLst/>
+          </a:prstGeom>
+          <a:noFill/>
+        </p:spPr>
+        <p:txBody>
+          <a:bodyPr wrap="square" lIns="0" rIns="0" tIns="0" bIns="0" anchor="ctr">
+            <a:spAutoFit/>
+          </a:bodyPr>
+          <a:lstStyle/>
+          <a:p>
+            <a:pPr algn="l"/>
+            <a:r>
+              <a:rPr sz="1300" b="0">
+                <a:solidFill>
+                  <a:srgbClr val="1A2530"/>
+                </a:solidFill>
+                <a:latin typeface="Segoe UI"/>
+              </a:rPr>
+              <a:t>Live at  </a:t>
+            </a:r>
+            <a:r>
+              <a:rPr sz="1400" b="1">
+                <a:solidFill>
+                  <a:srgbClr val="112A40"/>
+                </a:solidFill>
+                <a:latin typeface="Segoe UI Semibold"/>
+              </a:rPr>
+              <a:t>https://ccms-6dut.onrender.com</a:t>
+            </a:r>
+          </a:p>
+          <a:p>
+            <a:pPr algn="l">
+              <a:spcAft>
+                <a:spcPts val="0"/>
+              </a:spcAft>
+            </a:pPr>
+            <a:r>
+              <a:rPr sz="1100" b="0">
+                <a:solidFill>
+                  <a:srgbClr val="5A6B78"/>
+                </a:solidFill>
+                <a:latin typeface="Segoe UI"/>
+              </a:rPr>
+              <a:t>Deployed as a single web service on managed PostgreSQL, with production security enabled.</a:t>
+            </a:r>
+          </a:p>
+        </p:txBody>
+      </p:sp>
+      <p:sp>
+        <p:nvSpPr>
+          <p:cNvPr id="12" name="Rounded Rectangle 11"/>
+          <p:cNvSpPr/>
+          <p:nvPr/>
+        </p:nvSpPr>
+        <p:spPr>
+          <a:xfrm>
+            <a:off x="502920" y="2514600"/>
+            <a:ext cx="5440680" cy="1700784"/>
+          </a:xfrm>
+          <a:prstGeom prst="roundRect">
+            <a:avLst>
+              <a:gd name="adj" fmla="val 5000"/>
+            </a:avLst>
+          </a:prstGeom>
+          <a:solidFill>
+            <a:srgbClr val="FFFFFF"/>
+          </a:solidFill>
+          <a:ln w="12700">
+            <a:solidFill>
+              <a:srgbClr val="D5DDE3"/>
+            </a:solidFill>
+          </a:ln>
+          <a:effectLst/>
+        </p:spPr>
+        <p:style>
+          <a:lnRef idx="1">
+            <a:schemeClr val="accent1"/>
+          </a:lnRef>
+          <a:fillRef idx="3">
+            <a:schemeClr val="accent1"/>
+          </a:fillRef>
+          <a:effectRef idx="2">
+            <a:schemeClr val="accent1"/>
+          </a:effectRef>
+          <a:fontRef idx="minor">
+            <a:schemeClr val="lt1"/>
+          </a:fontRef>
+        </p:style>
+        <p:txBody>
+          <a:bodyPr rtlCol="0" anchor="ctr"/>
+          <a:lstStyle/>
+          <a:p>
+            <a:pPr algn="ctr"/>
+          </a:p>
+        </p:txBody>
+      </p:sp>
+      <p:sp>
+        <p:nvSpPr>
+          <p:cNvPr id="13" name="Rectangle 12"/>
+          <p:cNvSpPr/>
+          <p:nvPr/>
+        </p:nvSpPr>
+        <p:spPr>
+          <a:xfrm>
+            <a:off x="502920" y="2514600"/>
+            <a:ext cx="5440680" cy="91440"/>
+          </a:xfrm>
+          <a:prstGeom prst="rect">
+            <a:avLst/>
+          </a:prstGeom>
+          <a:solidFill>
+            <a:srgbClr val="E0912F"/>
+          </a:solidFill>
+          <a:ln>
+            <a:noFill/>
+          </a:ln>
+          <a:effectLst/>
+        </p:spPr>
+        <p:style>
+          <a:lnRef idx="1">
+            <a:schemeClr val="accent1"/>
+          </a:lnRef>
+          <a:fillRef idx="3">
+            <a:schemeClr val="accent1"/>
+          </a:fillRef>
+          <a:effectRef idx="2">
+            <a:schemeClr val="accent1"/>
+          </a:effectRef>
+          <a:fontRef idx="minor">
+            <a:schemeClr val="lt1"/>
+          </a:fontRef>
+        </p:style>
+        <p:txBody>
+          <a:bodyPr rtlCol="0" anchor="ctr"/>
+          <a:lstStyle/>
+          <a:p>
+            <a:pPr algn="ctr"/>
+          </a:p>
+        </p:txBody>
+      </p:sp>
+      <p:sp>
+        <p:nvSpPr>
+          <p:cNvPr id="14" name="TextBox 13"/>
+          <p:cNvSpPr txBox="1"/>
+          <p:nvPr/>
+        </p:nvSpPr>
+        <p:spPr>
+          <a:xfrm>
+            <a:off x="777240" y="2752344"/>
+            <a:ext cx="4983480" cy="237744"/>
+          </a:xfrm>
+          <a:prstGeom prst="rect">
+            <a:avLst/>
+          </a:prstGeom>
+          <a:noFill/>
+        </p:spPr>
+        <p:txBody>
+          <a:bodyPr wrap="square" lIns="0" rIns="0" tIns="0" bIns="0" anchor="t">
+            <a:spAutoFit/>
+          </a:bodyPr>
+          <a:lstStyle/>
+          <a:p>
+            <a:pPr algn="l"/>
+            <a:r>
+              <a:rPr sz="950" b="1">
+                <a:solidFill>
+                  <a:srgbClr val="E0912F"/>
+                </a:solidFill>
+                <a:latin typeface="Segoe UI"/>
+              </a:rPr>
+              <a:t>ARCHITECTURE</a:t>
+            </a:r>
+          </a:p>
+        </p:txBody>
+      </p:sp>
+      <p:sp>
+        <p:nvSpPr>
+          <p:cNvPr id="15" name="TextBox 14"/>
+          <p:cNvSpPr txBox="1"/>
+          <p:nvPr/>
+        </p:nvSpPr>
+        <p:spPr>
+          <a:xfrm>
+            <a:off x="777240" y="3008376"/>
+            <a:ext cx="4983480" cy="365760"/>
+          </a:xfrm>
+          <a:prstGeom prst="rect">
+            <a:avLst/>
+          </a:prstGeom>
+          <a:noFill/>
+        </p:spPr>
+        <p:txBody>
+          <a:bodyPr wrap="square" lIns="0" rIns="0" tIns="0" bIns="0" anchor="t">
+            <a:spAutoFit/>
+          </a:bodyPr>
+          <a:lstStyle/>
+          <a:p>
+            <a:pPr algn="l"/>
+            <a:r>
+              <a:rPr sz="1500" b="1">
+                <a:solidFill>
+                  <a:srgbClr val="112A40"/>
+                </a:solidFill>
+                <a:latin typeface="Segoe UI Semibold"/>
+              </a:rPr>
+              <a:t>One service, one origin</a:t>
+            </a:r>
+          </a:p>
+        </p:txBody>
+      </p:sp>
+      <p:sp>
+        <p:nvSpPr>
+          <p:cNvPr id="16" name="TextBox 15"/>
+          <p:cNvSpPr txBox="1"/>
+          <p:nvPr/>
+        </p:nvSpPr>
+        <p:spPr>
+          <a:xfrm>
+            <a:off x="777240" y="3410712"/>
+            <a:ext cx="4937760" cy="740664"/>
+          </a:xfrm>
+          <a:prstGeom prst="rect">
+            <a:avLst/>
+          </a:prstGeom>
+          <a:noFill/>
+        </p:spPr>
+        <p:txBody>
+          <a:bodyPr wrap="square" lIns="0" rIns="0" tIns="0" bIns="0" anchor="t">
+            <a:spAutoFit/>
+          </a:bodyPr>
+          <a:lstStyle/>
+          <a:p>
+            <a:pPr algn="l">
+              <a:lnSpc>
+                <a:spcPct val="108000"/>
+              </a:lnSpc>
+            </a:pPr>
+            <a:r>
+              <a:rPr sz="1050" b="0">
+                <a:solidFill>
+                  <a:srgbClr val="5A6B78"/>
+                </a:solidFill>
+                <a:latin typeface="Segoe UI"/>
+              </a:rPr>
+              <a:t>The Express API also serves the SPA — a single origin, so no CORS or cross-domain cookie config. Simpler and more secure.</a:t>
+            </a:r>
+          </a:p>
+        </p:txBody>
+      </p:sp>
+      <p:sp>
+        <p:nvSpPr>
+          <p:cNvPr id="17" name="Rounded Rectangle 16"/>
+          <p:cNvSpPr/>
+          <p:nvPr/>
+        </p:nvSpPr>
+        <p:spPr>
+          <a:xfrm>
+            <a:off x="6254496" y="2514600"/>
+            <a:ext cx="5440680" cy="1700784"/>
+          </a:xfrm>
+          <a:prstGeom prst="roundRect">
+            <a:avLst>
+              <a:gd name="adj" fmla="val 5000"/>
+            </a:avLst>
+          </a:prstGeom>
+          <a:solidFill>
+            <a:srgbClr val="FFFFFF"/>
+          </a:solidFill>
+          <a:ln w="12700">
+            <a:solidFill>
+              <a:srgbClr val="D5DDE3"/>
+            </a:solidFill>
+          </a:ln>
+          <a:effectLst/>
+        </p:spPr>
+        <p:style>
+          <a:lnRef idx="1">
+            <a:schemeClr val="accent1"/>
+          </a:lnRef>
+          <a:fillRef idx="3">
+            <a:schemeClr val="accent1"/>
+          </a:fillRef>
+          <a:effectRef idx="2">
+            <a:schemeClr val="accent1"/>
+          </a:effectRef>
+          <a:fontRef idx="minor">
+            <a:schemeClr val="lt1"/>
+          </a:fontRef>
+        </p:style>
+        <p:txBody>
+          <a:bodyPr rtlCol="0" anchor="ctr"/>
+          <a:lstStyle/>
+          <a:p>
+            <a:pPr algn="ctr"/>
+          </a:p>
+        </p:txBody>
+      </p:sp>
+      <p:sp>
+        <p:nvSpPr>
+          <p:cNvPr id="18" name="Rectangle 17"/>
+          <p:cNvSpPr/>
+          <p:nvPr/>
+        </p:nvSpPr>
+        <p:spPr>
+          <a:xfrm>
+            <a:off x="6254496" y="2514600"/>
+            <a:ext cx="5440680" cy="91440"/>
+          </a:xfrm>
+          <a:prstGeom prst="rect">
+            <a:avLst/>
+          </a:prstGeom>
+          <a:solidFill>
+            <a:srgbClr val="E0912F"/>
+          </a:solidFill>
+          <a:ln>
+            <a:noFill/>
+          </a:ln>
+          <a:effectLst/>
+        </p:spPr>
+        <p:style>
+          <a:lnRef idx="1">
+            <a:schemeClr val="accent1"/>
+          </a:lnRef>
+          <a:fillRef idx="3">
+            <a:schemeClr val="accent1"/>
+          </a:fillRef>
+          <a:effectRef idx="2">
+            <a:schemeClr val="accent1"/>
+          </a:effectRef>
+          <a:fontRef idx="minor">
+            <a:schemeClr val="lt1"/>
+          </a:fontRef>
+        </p:style>
+        <p:txBody>
+          <a:bodyPr rtlCol="0" anchor="ctr"/>
+          <a:lstStyle/>
+          <a:p>
+            <a:pPr algn="ctr"/>
+          </a:p>
+        </p:txBody>
+      </p:sp>
+      <p:sp>
+        <p:nvSpPr>
+          <p:cNvPr id="19" name="TextBox 18"/>
+          <p:cNvSpPr txBox="1"/>
+          <p:nvPr/>
+        </p:nvSpPr>
+        <p:spPr>
+          <a:xfrm>
+            <a:off x="6528816" y="2752344"/>
+            <a:ext cx="4983480" cy="237744"/>
+          </a:xfrm>
+          <a:prstGeom prst="rect">
+            <a:avLst/>
+          </a:prstGeom>
+          <a:noFill/>
+        </p:spPr>
+        <p:txBody>
+          <a:bodyPr wrap="square" lIns="0" rIns="0" tIns="0" bIns="0" anchor="t">
+            <a:spAutoFit/>
+          </a:bodyPr>
+          <a:lstStyle/>
+          <a:p>
+            <a:pPr algn="l"/>
+            <a:r>
+              <a:rPr sz="950" b="1">
+                <a:solidFill>
+                  <a:srgbClr val="E0912F"/>
+                </a:solidFill>
+                <a:latin typeface="Segoe UI"/>
+              </a:rPr>
+              <a:t>DATABASE</a:t>
+            </a:r>
+          </a:p>
+        </p:txBody>
+      </p:sp>
+      <p:sp>
+        <p:nvSpPr>
+          <p:cNvPr id="20" name="TextBox 19"/>
+          <p:cNvSpPr txBox="1"/>
+          <p:nvPr/>
+        </p:nvSpPr>
+        <p:spPr>
+          <a:xfrm>
+            <a:off x="6528816" y="3008376"/>
+            <a:ext cx="4983480" cy="365760"/>
+          </a:xfrm>
+          <a:prstGeom prst="rect">
+            <a:avLst/>
+          </a:prstGeom>
+          <a:noFill/>
+        </p:spPr>
+        <p:txBody>
+          <a:bodyPr wrap="square" lIns="0" rIns="0" tIns="0" bIns="0" anchor="t">
+            <a:spAutoFit/>
+          </a:bodyPr>
+          <a:lstStyle/>
+          <a:p>
+            <a:pPr algn="l"/>
+            <a:r>
+              <a:rPr sz="1500" b="1">
+                <a:solidFill>
+                  <a:srgbClr val="112A40"/>
+                </a:solidFill>
+                <a:latin typeface="Segoe UI Semibold"/>
+              </a:rPr>
+              <a:t>Managed Postgres, TLS on</a:t>
+            </a:r>
+          </a:p>
+        </p:txBody>
+      </p:sp>
+      <p:sp>
+        <p:nvSpPr>
+          <p:cNvPr id="21" name="TextBox 20"/>
+          <p:cNvSpPr txBox="1"/>
+          <p:nvPr/>
+        </p:nvSpPr>
+        <p:spPr>
+          <a:xfrm>
+            <a:off x="6528816" y="3410712"/>
+            <a:ext cx="4937760" cy="740664"/>
+          </a:xfrm>
+          <a:prstGeom prst="rect">
+            <a:avLst/>
+          </a:prstGeom>
+          <a:noFill/>
+        </p:spPr>
+        <p:txBody>
+          <a:bodyPr wrap="square" lIns="0" rIns="0" tIns="0" bIns="0" anchor="t">
+            <a:spAutoFit/>
+          </a:bodyPr>
+          <a:lstStyle/>
+          <a:p>
+            <a:pPr algn="l">
+              <a:lnSpc>
+                <a:spcPct val="108000"/>
+              </a:lnSpc>
+            </a:pPr>
+            <a:r>
+              <a:rPr sz="1050" b="0">
+                <a:solidFill>
+                  <a:srgbClr val="5A6B78"/>
+                </a:solidFill>
+                <a:latin typeface="Segoe UI"/>
+              </a:rPr>
+              <a:t>A single DATABASE_URL with automatic TLS runs on Render, Neon, Railway, Supabase or RDS — zero code change from local dev.</a:t>
+            </a:r>
+          </a:p>
+        </p:txBody>
+      </p:sp>
+      <p:sp>
+        <p:nvSpPr>
+          <p:cNvPr id="22" name="Rounded Rectangle 21"/>
+          <p:cNvSpPr/>
+          <p:nvPr/>
+        </p:nvSpPr>
+        <p:spPr>
+          <a:xfrm>
+            <a:off x="502920" y="4343400"/>
+            <a:ext cx="5440680" cy="1700784"/>
+          </a:xfrm>
+          <a:prstGeom prst="roundRect">
+            <a:avLst>
+              <a:gd name="adj" fmla="val 5000"/>
+            </a:avLst>
+          </a:prstGeom>
+          <a:solidFill>
+            <a:srgbClr val="FFFFFF"/>
+          </a:solidFill>
+          <a:ln w="12700">
+            <a:solidFill>
+              <a:srgbClr val="D5DDE3"/>
+            </a:solidFill>
+          </a:ln>
+          <a:effectLst/>
+        </p:spPr>
+        <p:style>
+          <a:lnRef idx="1">
+            <a:schemeClr val="accent1"/>
+          </a:lnRef>
+          <a:fillRef idx="3">
+            <a:schemeClr val="accent1"/>
+          </a:fillRef>
+          <a:effectRef idx="2">
+            <a:schemeClr val="accent1"/>
+          </a:effectRef>
+          <a:fontRef idx="minor">
+            <a:schemeClr val="lt1"/>
+          </a:fontRef>
+        </p:style>
+        <p:txBody>
+          <a:bodyPr rtlCol="0" anchor="ctr"/>
+          <a:lstStyle/>
+          <a:p>
+            <a:pPr algn="ctr"/>
+          </a:p>
+        </p:txBody>
+      </p:sp>
+      <p:sp>
+        <p:nvSpPr>
+          <p:cNvPr id="23" name="Rectangle 22"/>
+          <p:cNvSpPr/>
+          <p:nvPr/>
+        </p:nvSpPr>
+        <p:spPr>
+          <a:xfrm>
+            <a:off x="502920" y="4343400"/>
+            <a:ext cx="5440680" cy="91440"/>
+          </a:xfrm>
+          <a:prstGeom prst="rect">
+            <a:avLst/>
+          </a:prstGeom>
+          <a:solidFill>
+            <a:srgbClr val="E0912F"/>
+          </a:solidFill>
+          <a:ln>
+            <a:noFill/>
+          </a:ln>
+          <a:effectLst/>
+        </p:spPr>
+        <p:style>
+          <a:lnRef idx="1">
+            <a:schemeClr val="accent1"/>
+          </a:lnRef>
+          <a:fillRef idx="3">
+            <a:schemeClr val="accent1"/>
+          </a:fillRef>
+          <a:effectRef idx="2">
+            <a:schemeClr val="accent1"/>
+          </a:effectRef>
+          <a:fontRef idx="minor">
+            <a:schemeClr val="lt1"/>
+          </a:fontRef>
+        </p:style>
+        <p:txBody>
+          <a:bodyPr rtlCol="0" anchor="ctr"/>
+          <a:lstStyle/>
+          <a:p>
+            <a:pPr algn="ctr"/>
+          </a:p>
+        </p:txBody>
+      </p:sp>
+      <p:sp>
+        <p:nvSpPr>
+          <p:cNvPr id="24" name="TextBox 23"/>
+          <p:cNvSpPr txBox="1"/>
+          <p:nvPr/>
+        </p:nvSpPr>
+        <p:spPr>
+          <a:xfrm>
+            <a:off x="777240" y="4581144"/>
+            <a:ext cx="4983480" cy="237744"/>
+          </a:xfrm>
+          <a:prstGeom prst="rect">
+            <a:avLst/>
+          </a:prstGeom>
+          <a:noFill/>
+        </p:spPr>
+        <p:txBody>
+          <a:bodyPr wrap="square" lIns="0" rIns="0" tIns="0" bIns="0" anchor="t">
+            <a:spAutoFit/>
+          </a:bodyPr>
+          <a:lstStyle/>
+          <a:p>
+            <a:pPr algn="l"/>
+            <a:r>
+              <a:rPr sz="950" b="1">
+                <a:solidFill>
+                  <a:srgbClr val="E0912F"/>
+                </a:solidFill>
+                <a:latin typeface="Segoe UI"/>
+              </a:rPr>
+              <a:t>HARDENED</a:t>
+            </a:r>
+          </a:p>
+        </p:txBody>
+      </p:sp>
+      <p:sp>
+        <p:nvSpPr>
+          <p:cNvPr id="25" name="TextBox 24"/>
+          <p:cNvSpPr txBox="1"/>
+          <p:nvPr/>
+        </p:nvSpPr>
+        <p:spPr>
+          <a:xfrm>
+            <a:off x="777240" y="4837176"/>
+            <a:ext cx="4983480" cy="365760"/>
+          </a:xfrm>
+          <a:prstGeom prst="rect">
+            <a:avLst/>
+          </a:prstGeom>
+          <a:noFill/>
+        </p:spPr>
+        <p:txBody>
+          <a:bodyPr wrap="square" lIns="0" rIns="0" tIns="0" bIns="0" anchor="t">
+            <a:spAutoFit/>
+          </a:bodyPr>
+          <a:lstStyle/>
+          <a:p>
+            <a:pPr algn="l"/>
+            <a:r>
+              <a:rPr sz="1500" b="1">
+                <a:solidFill>
+                  <a:srgbClr val="112A40"/>
+                </a:solidFill>
+                <a:latin typeface="Segoe UI Semibold"/>
+              </a:rPr>
+              <a:t>Production-ready by default</a:t>
+            </a:r>
+          </a:p>
+        </p:txBody>
+      </p:sp>
+      <p:sp>
+        <p:nvSpPr>
+          <p:cNvPr id="26" name="TextBox 25"/>
+          <p:cNvSpPr txBox="1"/>
+          <p:nvPr/>
+        </p:nvSpPr>
+        <p:spPr>
+          <a:xfrm>
+            <a:off x="777240" y="5239512"/>
+            <a:ext cx="4937760" cy="740664"/>
+          </a:xfrm>
+          <a:prstGeom prst="rect">
+            <a:avLst/>
+          </a:prstGeom>
+          <a:noFill/>
+        </p:spPr>
+        <p:txBody>
+          <a:bodyPr wrap="square" lIns="0" rIns="0" tIns="0" bIns="0" anchor="t">
+            <a:spAutoFit/>
+          </a:bodyPr>
+          <a:lstStyle/>
+          <a:p>
+            <a:pPr algn="l">
+              <a:lnSpc>
+                <a:spcPct val="108000"/>
+              </a:lnSpc>
+            </a:pPr>
+            <a:r>
+              <a:rPr sz="1050" b="0">
+                <a:solidFill>
+                  <a:srgbClr val="5A6B78"/>
+                </a:solidFill>
+                <a:latin typeface="Segoe UI"/>
+              </a:rPr>
+              <a:t>Secure cookies, HSTS, HTTPS-only, a boot check that refuses a weak JWT secret, and one-time rotation of every seeded password.</a:t>
+            </a:r>
+          </a:p>
+        </p:txBody>
+      </p:sp>
+      <p:sp>
+        <p:nvSpPr>
+          <p:cNvPr id="27" name="Rounded Rectangle 26"/>
+          <p:cNvSpPr/>
+          <p:nvPr/>
+        </p:nvSpPr>
+        <p:spPr>
+          <a:xfrm>
+            <a:off x="6254496" y="4343400"/>
+            <a:ext cx="5440680" cy="1700784"/>
+          </a:xfrm>
+          <a:prstGeom prst="roundRect">
+            <a:avLst>
+              <a:gd name="adj" fmla="val 5000"/>
+            </a:avLst>
+          </a:prstGeom>
+          <a:solidFill>
+            <a:srgbClr val="FFFFFF"/>
+          </a:solidFill>
+          <a:ln w="12700">
+            <a:solidFill>
+              <a:srgbClr val="D5DDE3"/>
+            </a:solidFill>
+          </a:ln>
+          <a:effectLst/>
+        </p:spPr>
+        <p:style>
+          <a:lnRef idx="1">
+            <a:schemeClr val="accent1"/>
+          </a:lnRef>
+          <a:fillRef idx="3">
+            <a:schemeClr val="accent1"/>
+          </a:fillRef>
+          <a:effectRef idx="2">
+            <a:schemeClr val="accent1"/>
+          </a:effectRef>
+          <a:fontRef idx="minor">
+            <a:schemeClr val="lt1"/>
+          </a:fontRef>
+        </p:style>
+        <p:txBody>
+          <a:bodyPr rtlCol="0" anchor="ctr"/>
+          <a:lstStyle/>
+          <a:p>
+            <a:pPr algn="ctr"/>
+          </a:p>
+        </p:txBody>
+      </p:sp>
+      <p:sp>
+        <p:nvSpPr>
+          <p:cNvPr id="28" name="Rectangle 27"/>
+          <p:cNvSpPr/>
+          <p:nvPr/>
+        </p:nvSpPr>
+        <p:spPr>
+          <a:xfrm>
+            <a:off x="6254496" y="4343400"/>
+            <a:ext cx="5440680" cy="91440"/>
+          </a:xfrm>
+          <a:prstGeom prst="rect">
+            <a:avLst/>
+          </a:prstGeom>
+          <a:solidFill>
+            <a:srgbClr val="E0912F"/>
+          </a:solidFill>
+          <a:ln>
+            <a:noFill/>
+          </a:ln>
+          <a:effectLst/>
+        </p:spPr>
+        <p:style>
+          <a:lnRef idx="1">
+            <a:schemeClr val="accent1"/>
+          </a:lnRef>
+          <a:fillRef idx="3">
+            <a:schemeClr val="accent1"/>
+          </a:fillRef>
+          <a:effectRef idx="2">
+            <a:schemeClr val="accent1"/>
+          </a:effectRef>
+          <a:fontRef idx="minor">
+            <a:schemeClr val="lt1"/>
+          </a:fontRef>
+        </p:style>
+        <p:txBody>
+          <a:bodyPr rtlCol="0" anchor="ctr"/>
+          <a:lstStyle/>
+          <a:p>
+            <a:pPr algn="ctr"/>
+          </a:p>
+        </p:txBody>
+      </p:sp>
+      <p:sp>
+        <p:nvSpPr>
+          <p:cNvPr id="29" name="TextBox 28"/>
+          <p:cNvSpPr txBox="1"/>
+          <p:nvPr/>
+        </p:nvSpPr>
+        <p:spPr>
+          <a:xfrm>
+            <a:off x="6528816" y="4581144"/>
+            <a:ext cx="4983480" cy="237744"/>
+          </a:xfrm>
+          <a:prstGeom prst="rect">
+            <a:avLst/>
+          </a:prstGeom>
+          <a:noFill/>
+        </p:spPr>
+        <p:txBody>
+          <a:bodyPr wrap="square" lIns="0" rIns="0" tIns="0" bIns="0" anchor="t">
+            <a:spAutoFit/>
+          </a:bodyPr>
+          <a:lstStyle/>
+          <a:p>
+            <a:pPr algn="l"/>
+            <a:r>
+              <a:rPr sz="950" b="1">
+                <a:solidFill>
+                  <a:srgbClr val="E0912F"/>
+                </a:solidFill>
+                <a:latin typeface="Segoe UI"/>
+              </a:rPr>
+              <a:t>EMAIL</a:t>
+            </a:r>
+          </a:p>
+        </p:txBody>
+      </p:sp>
+      <p:sp>
+        <p:nvSpPr>
+          <p:cNvPr id="30" name="TextBox 29"/>
+          <p:cNvSpPr txBox="1"/>
+          <p:nvPr/>
+        </p:nvSpPr>
+        <p:spPr>
+          <a:xfrm>
+            <a:off x="6528816" y="4837176"/>
+            <a:ext cx="4983480" cy="365760"/>
+          </a:xfrm>
+          <a:prstGeom prst="rect">
+            <a:avLst/>
+          </a:prstGeom>
+          <a:noFill/>
+        </p:spPr>
+        <p:txBody>
+          <a:bodyPr wrap="square" lIns="0" rIns="0" tIns="0" bIns="0" anchor="t">
+            <a:spAutoFit/>
+          </a:bodyPr>
+          <a:lstStyle/>
+          <a:p>
+            <a:pPr algn="l"/>
+            <a:r>
+              <a:rPr sz="1500" b="1">
+                <a:solidFill>
+                  <a:srgbClr val="112A40"/>
+                </a:solidFill>
+                <a:latin typeface="Segoe UI Semibold"/>
+              </a:rPr>
+              <a:t>Real inbox delivery</a:t>
+            </a:r>
+          </a:p>
+        </p:txBody>
+      </p:sp>
+      <p:sp>
+        <p:nvSpPr>
+          <p:cNvPr id="31" name="TextBox 30"/>
+          <p:cNvSpPr txBox="1"/>
+          <p:nvPr/>
+        </p:nvSpPr>
+        <p:spPr>
+          <a:xfrm>
+            <a:off x="6528816" y="5239512"/>
+            <a:ext cx="4937760" cy="740664"/>
+          </a:xfrm>
+          <a:prstGeom prst="rect">
+            <a:avLst/>
+          </a:prstGeom>
+          <a:noFill/>
+        </p:spPr>
+        <p:txBody>
+          <a:bodyPr wrap="square" lIns="0" rIns="0" tIns="0" bIns="0" anchor="t">
+            <a:spAutoFit/>
+          </a:bodyPr>
+          <a:lstStyle/>
+          <a:p>
+            <a:pPr algn="l">
+              <a:lnSpc>
+                <a:spcPct val="108000"/>
+              </a:lnSpc>
+            </a:pPr>
+            <a:r>
+              <a:rPr sz="1050" b="0">
+                <a:solidFill>
+                  <a:srgbClr val="5A6B78"/>
+                </a:solidFill>
+                <a:latin typeface="Segoe UI"/>
+              </a:rPr>
+              <a:t>Customer and staff notifications go out over SMTP (Gmail / Brevo / any relay) and are mirrored to the in-app Emails trail.</a:t>
             </a:r>
           </a:p>
         </p:txBody>

</xml_diff>

<commit_message>
Fix deck: contain overflowing rows on the Architecture & Security slides
The CROSS-CUTTING (Architecture) and DEFENCE IN DEPTH (Security) panels
were too short, so their second row of chips spilled out below the panel.
Extend both panels to enclose row 2, nudge the request-flow caption down,
and tighten two exception-path subtitles to one line.
</commit_message>
<xml_diff>
--- a/CCMS-Presentation.pptx
+++ b/CCMS-Presentation.pptx
@@ -7165,7 +7165,7 @@
         <p:spPr>
           <a:xfrm>
             <a:off x="502920" y="4828032"/>
-            <a:ext cx="11192256" cy="960120"/>
+            <a:ext cx="11192256" cy="1234440"/>
           </a:xfrm>
           <a:prstGeom prst="roundRect">
             <a:avLst/>
@@ -17933,7 +17933,7 @@
                 </a:solidFill>
                 <a:latin typeface="Segoe UI"/>
               </a:rPr>
-              <a:t>We need more information to proceed — reply to resume</a:t>
+              <a:t>We need more info — reply to resume</a:t>
             </a:r>
           </a:p>
         </p:txBody>
@@ -18173,7 +18173,7 @@
                 </a:solidFill>
                 <a:latin typeface="Segoe UI"/>
               </a:rPr>
-              <a:t>No customer response within the 30-day SLA window</a:t>
+              <a:t>No reply within the 30-day SLA window</a:t>
             </a:r>
           </a:p>
         </p:txBody>
@@ -19725,7 +19725,7 @@
         <p:spPr>
           <a:xfrm>
             <a:off x="0" y="0"/>
-            <a:ext cx="12191695" cy="6858000"/>
+            <a:ext cx="12191695" cy="1170432"/>
           </a:xfrm>
           <a:prstGeom prst="rect">
             <a:avLst/>
@@ -19768,8 +19768,8 @@
         </p:nvSpPr>
         <p:spPr>
           <a:xfrm>
-            <a:off x="0" y="0"/>
-            <a:ext cx="256032" cy="6858000"/>
+            <a:off x="0" y="1170432"/>
+            <a:ext cx="12191695" cy="54864"/>
           </a:xfrm>
           <a:prstGeom prst="rect">
             <a:avLst/>
@@ -19812,8 +19812,8 @@
         </p:nvSpPr>
         <p:spPr>
           <a:xfrm>
-            <a:off x="822960" y="1005840"/>
-            <a:ext cx="10058400" cy="457200"/>
+            <a:off x="502920" y="219456"/>
+            <a:ext cx="10058400" cy="274320"/>
           </a:xfrm>
           <a:prstGeom prst="rect">
             <a:avLst/>
@@ -19821,30 +19821,20 @@
           <a:noFill/>
         </p:spPr>
         <p:txBody>
-          <a:bodyPr wrap="square" anchor="t" lIns="0" rIns="0" tIns="0" bIns="0">
+          <a:bodyPr wrap="square" lIns="0" rIns="0" tIns="0" bIns="0" anchor="t">
             <a:spAutoFit/>
           </a:bodyPr>
           <a:lstStyle/>
           <a:p>
-            <a:pPr algn="l">
-              <a:lnSpc>
-                <a:spcPct val="100000"/>
-              </a:lnSpc>
-              <a:spcBef>
-                <a:spcPts val="0"/>
-              </a:spcBef>
-              <a:spcAft>
-                <a:spcPts val="400"/>
-              </a:spcAft>
-            </a:pPr>
-            <a:r>
-              <a:rPr sz="1300" b="1">
+            <a:pPr algn="l"/>
+            <a:r>
+              <a:rPr sz="1100" b="1">
                 <a:solidFill>
                   <a:srgbClr val="E0912F"/>
                 </a:solidFill>
                 <a:latin typeface="Segoe UI"/>
               </a:rPr>
-              <a:t>CONCLUSION</a:t>
+              <a:t>09 · DEPLOYMENT</a:t>
             </a:r>
           </a:p>
         </p:txBody>
@@ -19857,8 +19847,8 @@
         </p:nvSpPr>
         <p:spPr>
           <a:xfrm>
-            <a:off x="777240" y="1371600"/>
-            <a:ext cx="10607040" cy="1371600"/>
+            <a:off x="502920" y="457200"/>
+            <a:ext cx="11155680" cy="640080"/>
           </a:xfrm>
           <a:prstGeom prst="rect">
             <a:avLst/>
@@ -19866,69 +19856,199 @@
           <a:noFill/>
         </p:spPr>
         <p:txBody>
-          <a:bodyPr wrap="square" anchor="t" lIns="0" rIns="0" tIns="0" bIns="0">
+          <a:bodyPr wrap="square" lIns="0" rIns="0" tIns="0" bIns="0" anchor="t">
             <a:spAutoFit/>
           </a:bodyPr>
           <a:lstStyle/>
           <a:p>
-            <a:pPr algn="l">
-              <a:lnSpc>
-                <a:spcPct val="100000"/>
-              </a:lnSpc>
-              <a:spcBef>
-                <a:spcPts val="0"/>
-              </a:spcBef>
-              <a:spcAft>
-                <a:spcPts val="200"/>
-              </a:spcAft>
-            </a:pPr>
-            <a:r>
-              <a:rPr sz="3400" b="1">
+            <a:pPr algn="l"/>
+            <a:r>
+              <a:rPr sz="2600" b="1">
                 <a:solidFill>
                   <a:srgbClr val="FFFFFF"/>
                 </a:solidFill>
                 <a:latin typeface="Segoe UI Semibold"/>
               </a:rPr>
-              <a:t>A complete, governed, SAP-ready</a:t>
-            </a:r>
-          </a:p>
-          <a:p>
-            <a:pPr algn="l">
-              <a:lnSpc>
-                <a:spcPct val="100000"/>
-              </a:lnSpc>
-              <a:spcBef>
-                <a:spcPts val="0"/>
-              </a:spcBef>
-              <a:spcAft>
-                <a:spcPts val="200"/>
-              </a:spcAft>
-            </a:pPr>
-            <a:r>
-              <a:rPr sz="3400" b="1">
-                <a:solidFill>
-                  <a:srgbClr val="FFFFFF"/>
-                </a:solidFill>
-                <a:latin typeface="Segoe UI Semibold"/>
-              </a:rPr>
-              <a:t>complaint management platform.</a:t>
-            </a:r>
-          </a:p>
-        </p:txBody>
-      </p:sp>
-      <p:sp>
-        <p:nvSpPr>
-          <p:cNvPr id="6" name="Oval 5"/>
+              <a:t>Deployed live on the internet</a:t>
+            </a:r>
+          </a:p>
+        </p:txBody>
+      </p:sp>
+      <p:sp>
+        <p:nvSpPr>
+          <p:cNvPr id="6" name="Rectangle 5"/>
           <p:cNvSpPr/>
           <p:nvPr/>
         </p:nvSpPr>
         <p:spPr>
           <a:xfrm>
-            <a:off x="822960" y="2944368"/>
-            <a:ext cx="146304" cy="146304"/>
-          </a:xfrm>
-          <a:prstGeom prst="ellipse">
-            <a:avLst/>
+            <a:off x="0" y="6510528"/>
+            <a:ext cx="12191695" cy="347472"/>
+          </a:xfrm>
+          <a:prstGeom prst="rect">
+            <a:avLst/>
+          </a:prstGeom>
+          <a:solidFill>
+            <a:srgbClr val="112A40"/>
+          </a:solidFill>
+          <a:ln>
+            <a:noFill/>
+          </a:ln>
+          <a:effectLst/>
+        </p:spPr>
+        <p:style>
+          <a:lnRef idx="1">
+            <a:schemeClr val="accent1"/>
+          </a:lnRef>
+          <a:fillRef idx="3">
+            <a:schemeClr val="accent1"/>
+          </a:fillRef>
+          <a:effectRef idx="2">
+            <a:schemeClr val="accent1"/>
+          </a:effectRef>
+          <a:fontRef idx="minor">
+            <a:schemeClr val="lt1"/>
+          </a:fontRef>
+        </p:style>
+        <p:txBody>
+          <a:bodyPr rtlCol="0" anchor="ctr"/>
+          <a:lstStyle/>
+          <a:p>
+            <a:pPr algn="ctr"/>
+          </a:p>
+        </p:txBody>
+      </p:sp>
+      <p:sp>
+        <p:nvSpPr>
+          <p:cNvPr id="7" name="TextBox 6"/>
+          <p:cNvSpPr txBox="1"/>
+          <p:nvPr/>
+        </p:nvSpPr>
+        <p:spPr>
+          <a:xfrm>
+            <a:off x="502920" y="6528816"/>
+            <a:ext cx="7315200" cy="310896"/>
+          </a:xfrm>
+          <a:prstGeom prst="rect">
+            <a:avLst/>
+          </a:prstGeom>
+          <a:noFill/>
+        </p:spPr>
+        <p:txBody>
+          <a:bodyPr wrap="square" lIns="0" rIns="0" tIns="0" bIns="0" anchor="t">
+            <a:spAutoFit/>
+          </a:bodyPr>
+          <a:lstStyle/>
+          <a:p>
+            <a:pPr algn="l"/>
+            <a:r>
+              <a:rPr sz="900" b="0">
+                <a:solidFill>
+                  <a:srgbClr val="B9C7D2"/>
+                </a:solidFill>
+                <a:latin typeface="Segoe UI"/>
+              </a:rPr>
+              <a:t>Customer Complaint Management System  ·  Orient Paper &amp; Mill</a:t>
+            </a:r>
+          </a:p>
+        </p:txBody>
+      </p:sp>
+      <p:sp>
+        <p:nvSpPr>
+          <p:cNvPr id="8" name="TextBox 7"/>
+          <p:cNvSpPr txBox="1"/>
+          <p:nvPr/>
+        </p:nvSpPr>
+        <p:spPr>
+          <a:xfrm>
+            <a:off x="10424160" y="6528816"/>
+            <a:ext cx="1280160" cy="310896"/>
+          </a:xfrm>
+          <a:prstGeom prst="rect">
+            <a:avLst/>
+          </a:prstGeom>
+          <a:noFill/>
+        </p:spPr>
+        <p:txBody>
+          <a:bodyPr wrap="square" lIns="0" rIns="0" tIns="0" bIns="0" anchor="t">
+            <a:spAutoFit/>
+          </a:bodyPr>
+          <a:lstStyle/>
+          <a:p>
+            <a:pPr algn="r"/>
+            <a:r>
+              <a:rPr sz="900" b="1">
+                <a:solidFill>
+                  <a:srgbClr val="E0912F"/>
+                </a:solidFill>
+                <a:latin typeface="Segoe UI"/>
+              </a:rPr>
+              <a:t>18</a:t>
+            </a:r>
+          </a:p>
+        </p:txBody>
+      </p:sp>
+      <p:sp>
+        <p:nvSpPr>
+          <p:cNvPr id="9" name="Rounded Rectangle 8"/>
+          <p:cNvSpPr/>
+          <p:nvPr/>
+        </p:nvSpPr>
+        <p:spPr>
+          <a:xfrm>
+            <a:off x="502920" y="1463040"/>
+            <a:ext cx="11183112" cy="841248"/>
+          </a:xfrm>
+          <a:prstGeom prst="roundRect">
+            <a:avLst>
+              <a:gd name="adj" fmla="val 10000"/>
+            </a:avLst>
+          </a:prstGeom>
+          <a:solidFill>
+            <a:srgbClr val="EEF2F5"/>
+          </a:solidFill>
+          <a:ln>
+            <a:noFill/>
+          </a:ln>
+          <a:effectLst/>
+        </p:spPr>
+        <p:style>
+          <a:lnRef idx="1">
+            <a:schemeClr val="accent1"/>
+          </a:lnRef>
+          <a:fillRef idx="3">
+            <a:schemeClr val="accent1"/>
+          </a:fillRef>
+          <a:effectRef idx="2">
+            <a:schemeClr val="accent1"/>
+          </a:effectRef>
+          <a:fontRef idx="minor">
+            <a:schemeClr val="lt1"/>
+          </a:fontRef>
+        </p:style>
+        <p:txBody>
+          <a:bodyPr rtlCol="0" anchor="ctr"/>
+          <a:lstStyle/>
+          <a:p>
+            <a:pPr algn="ctr"/>
+          </a:p>
+        </p:txBody>
+      </p:sp>
+      <p:sp>
+        <p:nvSpPr>
+          <p:cNvPr id="10" name="Rounded Rectangle 9"/>
+          <p:cNvSpPr/>
+          <p:nvPr/>
+        </p:nvSpPr>
+        <p:spPr>
+          <a:xfrm>
+            <a:off x="713232" y="1609344"/>
+            <a:ext cx="118872" cy="548640"/>
+          </a:xfrm>
+          <a:prstGeom prst="roundRect">
+            <a:avLst>
+              <a:gd name="adj" fmla="val 50000"/>
+            </a:avLst>
           </a:prstGeom>
           <a:solidFill>
             <a:srgbClr val="E0912F"/>
@@ -19962,14 +20082,14 @@
       </p:sp>
       <p:sp>
         <p:nvSpPr>
-          <p:cNvPr id="7" name="TextBox 6"/>
+          <p:cNvPr id="11" name="TextBox 10"/>
           <p:cNvSpPr txBox="1"/>
           <p:nvPr/>
         </p:nvSpPr>
         <p:spPr>
           <a:xfrm>
-            <a:off x="1143000" y="2880360"/>
-            <a:ext cx="9601200" cy="457200"/>
+            <a:off x="969264" y="1463040"/>
+            <a:ext cx="10424160" cy="841248"/>
           </a:xfrm>
           <a:prstGeom prst="rect">
             <a:avLst/>
@@ -19977,46 +20097,109 @@
           <a:noFill/>
         </p:spPr>
         <p:txBody>
-          <a:bodyPr wrap="square" anchor="t" lIns="0" rIns="0" tIns="0" bIns="0">
+          <a:bodyPr wrap="square" lIns="0" rIns="0" tIns="0" bIns="0" anchor="ctr">
             <a:spAutoFit/>
           </a:bodyPr>
           <a:lstStyle/>
           <a:p>
+            <a:pPr algn="l"/>
+            <a:r>
+              <a:rPr sz="1300" b="0">
+                <a:solidFill>
+                  <a:srgbClr val="1A2530"/>
+                </a:solidFill>
+                <a:latin typeface="Segoe UI"/>
+              </a:rPr>
+              <a:t>Live at  </a:t>
+            </a:r>
+            <a:r>
+              <a:rPr sz="1400" b="1">
+                <a:solidFill>
+                  <a:srgbClr val="112A40"/>
+                </a:solidFill>
+                <a:latin typeface="Segoe UI Semibold"/>
+              </a:rPr>
+              <a:t>https://ccms-6dut.onrender.com</a:t>
+            </a:r>
+          </a:p>
+          <a:p>
             <a:pPr algn="l">
-              <a:lnSpc>
-                <a:spcPct val="100000"/>
-              </a:lnSpc>
-              <a:spcBef>
+              <a:spcAft>
                 <a:spcPts val="0"/>
-              </a:spcBef>
-              <a:spcAft>
-                <a:spcPts val="400"/>
               </a:spcAft>
             </a:pPr>
             <a:r>
-              <a:rPr sz="1450" b="0">
-                <a:solidFill>
-                  <a:srgbClr val="D5DEE5"/>
+              <a:rPr sz="1100" b="0">
+                <a:solidFill>
+                  <a:srgbClr val="5A6B78"/>
                 </a:solidFill>
                 <a:latin typeface="Segoe UI"/>
               </a:rPr>
-              <a:t>Full 8-stage lifecycle with automated approval gates</a:t>
-            </a:r>
-          </a:p>
-        </p:txBody>
-      </p:sp>
-      <p:sp>
-        <p:nvSpPr>
-          <p:cNvPr id="8" name="Oval 7"/>
+              <a:t>Deployed as a single web service on managed PostgreSQL, with production security enabled.</a:t>
+            </a:r>
+          </a:p>
+        </p:txBody>
+      </p:sp>
+      <p:sp>
+        <p:nvSpPr>
+          <p:cNvPr id="12" name="Rounded Rectangle 11"/>
           <p:cNvSpPr/>
           <p:nvPr/>
         </p:nvSpPr>
         <p:spPr>
           <a:xfrm>
-            <a:off x="822960" y="3447288"/>
-            <a:ext cx="146304" cy="146304"/>
-          </a:xfrm>
-          <a:prstGeom prst="ellipse">
+            <a:off x="502920" y="2514600"/>
+            <a:ext cx="5440680" cy="1700784"/>
+          </a:xfrm>
+          <a:prstGeom prst="roundRect">
+            <a:avLst>
+              <a:gd name="adj" fmla="val 5000"/>
+            </a:avLst>
+          </a:prstGeom>
+          <a:solidFill>
+            <a:srgbClr val="FFFFFF"/>
+          </a:solidFill>
+          <a:ln w="12700">
+            <a:solidFill>
+              <a:srgbClr val="D5DDE3"/>
+            </a:solidFill>
+          </a:ln>
+          <a:effectLst/>
+        </p:spPr>
+        <p:style>
+          <a:lnRef idx="1">
+            <a:schemeClr val="accent1"/>
+          </a:lnRef>
+          <a:fillRef idx="3">
+            <a:schemeClr val="accent1"/>
+          </a:fillRef>
+          <a:effectRef idx="2">
+            <a:schemeClr val="accent1"/>
+          </a:effectRef>
+          <a:fontRef idx="minor">
+            <a:schemeClr val="lt1"/>
+          </a:fontRef>
+        </p:style>
+        <p:txBody>
+          <a:bodyPr rtlCol="0" anchor="ctr"/>
+          <a:lstStyle/>
+          <a:p>
+            <a:pPr algn="ctr"/>
+          </a:p>
+        </p:txBody>
+      </p:sp>
+      <p:sp>
+        <p:nvSpPr>
+          <p:cNvPr id="13" name="Rectangle 12"/>
+          <p:cNvSpPr/>
+          <p:nvPr/>
+        </p:nvSpPr>
+        <p:spPr>
+          <a:xfrm>
+            <a:off x="502920" y="2514600"/>
+            <a:ext cx="5440680" cy="91440"/>
+          </a:xfrm>
+          <a:prstGeom prst="rect">
             <a:avLst/>
           </a:prstGeom>
           <a:solidFill>
@@ -20051,14 +20234,14 @@
       </p:sp>
       <p:sp>
         <p:nvSpPr>
-          <p:cNvPr id="9" name="TextBox 8"/>
+          <p:cNvPr id="14" name="TextBox 13"/>
           <p:cNvSpPr txBox="1"/>
           <p:nvPr/>
         </p:nvSpPr>
         <p:spPr>
           <a:xfrm>
-            <a:off x="1143000" y="3383280"/>
-            <a:ext cx="9601200" cy="457200"/>
+            <a:off x="777240" y="2752344"/>
+            <a:ext cx="4983480" cy="237744"/>
           </a:xfrm>
           <a:prstGeom prst="rect">
             <a:avLst/>
@@ -20066,46 +20249,158 @@
           <a:noFill/>
         </p:spPr>
         <p:txBody>
-          <a:bodyPr wrap="square" anchor="t" lIns="0" rIns="0" tIns="0" bIns="0">
+          <a:bodyPr wrap="square" lIns="0" rIns="0" tIns="0" bIns="0" anchor="t">
             <a:spAutoFit/>
           </a:bodyPr>
           <a:lstStyle/>
           <a:p>
+            <a:pPr algn="l"/>
+            <a:r>
+              <a:rPr sz="950" b="1">
+                <a:solidFill>
+                  <a:srgbClr val="E0912F"/>
+                </a:solidFill>
+                <a:latin typeface="Segoe UI"/>
+              </a:rPr>
+              <a:t>ARCHITECTURE</a:t>
+            </a:r>
+          </a:p>
+        </p:txBody>
+      </p:sp>
+      <p:sp>
+        <p:nvSpPr>
+          <p:cNvPr id="15" name="TextBox 14"/>
+          <p:cNvSpPr txBox="1"/>
+          <p:nvPr/>
+        </p:nvSpPr>
+        <p:spPr>
+          <a:xfrm>
+            <a:off x="777240" y="3008376"/>
+            <a:ext cx="4983480" cy="365760"/>
+          </a:xfrm>
+          <a:prstGeom prst="rect">
+            <a:avLst/>
+          </a:prstGeom>
+          <a:noFill/>
+        </p:spPr>
+        <p:txBody>
+          <a:bodyPr wrap="square" lIns="0" rIns="0" tIns="0" bIns="0" anchor="t">
+            <a:spAutoFit/>
+          </a:bodyPr>
+          <a:lstStyle/>
+          <a:p>
+            <a:pPr algn="l"/>
+            <a:r>
+              <a:rPr sz="1500" b="1">
+                <a:solidFill>
+                  <a:srgbClr val="112A40"/>
+                </a:solidFill>
+                <a:latin typeface="Segoe UI Semibold"/>
+              </a:rPr>
+              <a:t>One service, one origin</a:t>
+            </a:r>
+          </a:p>
+        </p:txBody>
+      </p:sp>
+      <p:sp>
+        <p:nvSpPr>
+          <p:cNvPr id="16" name="TextBox 15"/>
+          <p:cNvSpPr txBox="1"/>
+          <p:nvPr/>
+        </p:nvSpPr>
+        <p:spPr>
+          <a:xfrm>
+            <a:off x="777240" y="3410712"/>
+            <a:ext cx="4937760" cy="740664"/>
+          </a:xfrm>
+          <a:prstGeom prst="rect">
+            <a:avLst/>
+          </a:prstGeom>
+          <a:noFill/>
+        </p:spPr>
+        <p:txBody>
+          <a:bodyPr wrap="square" lIns="0" rIns="0" tIns="0" bIns="0" anchor="t">
+            <a:spAutoFit/>
+          </a:bodyPr>
+          <a:lstStyle/>
+          <a:p>
             <a:pPr algn="l">
               <a:lnSpc>
-                <a:spcPct val="100000"/>
-              </a:lnSpc>
-              <a:spcBef>
-                <a:spcPts val="0"/>
-              </a:spcBef>
-              <a:spcAft>
-                <a:spcPts val="400"/>
-              </a:spcAft>
-            </a:pPr>
-            <a:r>
-              <a:rPr sz="1450" b="0">
-                <a:solidFill>
-                  <a:srgbClr val="D5DEE5"/>
+                <a:spcPct val="108000"/>
+              </a:lnSpc>
+            </a:pPr>
+            <a:r>
+              <a:rPr sz="1050" b="0">
+                <a:solidFill>
+                  <a:srgbClr val="5A6B78"/>
                 </a:solidFill>
                 <a:latin typeface="Segoe UI"/>
               </a:rPr>
-              <a:t>Live SAP S/4HANA integration across 6 touchpoints</a:t>
-            </a:r>
-          </a:p>
-        </p:txBody>
-      </p:sp>
-      <p:sp>
-        <p:nvSpPr>
-          <p:cNvPr id="10" name="Oval 9"/>
+              <a:t>The Express API also serves the SPA — a single origin, so no CORS or cross-domain cookie config. Simpler and more secure.</a:t>
+            </a:r>
+          </a:p>
+        </p:txBody>
+      </p:sp>
+      <p:sp>
+        <p:nvSpPr>
+          <p:cNvPr id="17" name="Rounded Rectangle 16"/>
           <p:cNvSpPr/>
           <p:nvPr/>
         </p:nvSpPr>
         <p:spPr>
           <a:xfrm>
-            <a:off x="822960" y="3950208"/>
-            <a:ext cx="146304" cy="146304"/>
-          </a:xfrm>
-          <a:prstGeom prst="ellipse">
+            <a:off x="6254496" y="2514600"/>
+            <a:ext cx="5440680" cy="1700784"/>
+          </a:xfrm>
+          <a:prstGeom prst="roundRect">
+            <a:avLst>
+              <a:gd name="adj" fmla="val 5000"/>
+            </a:avLst>
+          </a:prstGeom>
+          <a:solidFill>
+            <a:srgbClr val="FFFFFF"/>
+          </a:solidFill>
+          <a:ln w="12700">
+            <a:solidFill>
+              <a:srgbClr val="D5DDE3"/>
+            </a:solidFill>
+          </a:ln>
+          <a:effectLst/>
+        </p:spPr>
+        <p:style>
+          <a:lnRef idx="1">
+            <a:schemeClr val="accent1"/>
+          </a:lnRef>
+          <a:fillRef idx="3">
+            <a:schemeClr val="accent1"/>
+          </a:fillRef>
+          <a:effectRef idx="2">
+            <a:schemeClr val="accent1"/>
+          </a:effectRef>
+          <a:fontRef idx="minor">
+            <a:schemeClr val="lt1"/>
+          </a:fontRef>
+        </p:style>
+        <p:txBody>
+          <a:bodyPr rtlCol="0" anchor="ctr"/>
+          <a:lstStyle/>
+          <a:p>
+            <a:pPr algn="ctr"/>
+          </a:p>
+        </p:txBody>
+      </p:sp>
+      <p:sp>
+        <p:nvSpPr>
+          <p:cNvPr id="18" name="Rectangle 17"/>
+          <p:cNvSpPr/>
+          <p:nvPr/>
+        </p:nvSpPr>
+        <p:spPr>
+          <a:xfrm>
+            <a:off x="6254496" y="2514600"/>
+            <a:ext cx="5440680" cy="91440"/>
+          </a:xfrm>
+          <a:prstGeom prst="rect">
             <a:avLst/>
           </a:prstGeom>
           <a:solidFill>
@@ -20140,14 +20435,14 @@
       </p:sp>
       <p:sp>
         <p:nvSpPr>
-          <p:cNvPr id="11" name="TextBox 10"/>
+          <p:cNvPr id="19" name="TextBox 18"/>
           <p:cNvSpPr txBox="1"/>
           <p:nvPr/>
         </p:nvSpPr>
         <p:spPr>
           <a:xfrm>
-            <a:off x="1143000" y="3886200"/>
-            <a:ext cx="9601200" cy="457200"/>
+            <a:off x="6528816" y="2752344"/>
+            <a:ext cx="4983480" cy="237744"/>
           </a:xfrm>
           <a:prstGeom prst="rect">
             <a:avLst/>
@@ -20155,46 +20450,158 @@
           <a:noFill/>
         </p:spPr>
         <p:txBody>
-          <a:bodyPr wrap="square" anchor="t" lIns="0" rIns="0" tIns="0" bIns="0">
+          <a:bodyPr wrap="square" lIns="0" rIns="0" tIns="0" bIns="0" anchor="t">
             <a:spAutoFit/>
           </a:bodyPr>
           <a:lstStyle/>
           <a:p>
+            <a:pPr algn="l"/>
+            <a:r>
+              <a:rPr sz="950" b="1">
+                <a:solidFill>
+                  <a:srgbClr val="E0912F"/>
+                </a:solidFill>
+                <a:latin typeface="Segoe UI"/>
+              </a:rPr>
+              <a:t>DATABASE</a:t>
+            </a:r>
+          </a:p>
+        </p:txBody>
+      </p:sp>
+      <p:sp>
+        <p:nvSpPr>
+          <p:cNvPr id="20" name="TextBox 19"/>
+          <p:cNvSpPr txBox="1"/>
+          <p:nvPr/>
+        </p:nvSpPr>
+        <p:spPr>
+          <a:xfrm>
+            <a:off x="6528816" y="3008376"/>
+            <a:ext cx="4983480" cy="365760"/>
+          </a:xfrm>
+          <a:prstGeom prst="rect">
+            <a:avLst/>
+          </a:prstGeom>
+          <a:noFill/>
+        </p:spPr>
+        <p:txBody>
+          <a:bodyPr wrap="square" lIns="0" rIns="0" tIns="0" bIns="0" anchor="t">
+            <a:spAutoFit/>
+          </a:bodyPr>
+          <a:lstStyle/>
+          <a:p>
+            <a:pPr algn="l"/>
+            <a:r>
+              <a:rPr sz="1500" b="1">
+                <a:solidFill>
+                  <a:srgbClr val="112A40"/>
+                </a:solidFill>
+                <a:latin typeface="Segoe UI Semibold"/>
+              </a:rPr>
+              <a:t>Managed Postgres, TLS on</a:t>
+            </a:r>
+          </a:p>
+        </p:txBody>
+      </p:sp>
+      <p:sp>
+        <p:nvSpPr>
+          <p:cNvPr id="21" name="TextBox 20"/>
+          <p:cNvSpPr txBox="1"/>
+          <p:nvPr/>
+        </p:nvSpPr>
+        <p:spPr>
+          <a:xfrm>
+            <a:off x="6528816" y="3410712"/>
+            <a:ext cx="4937760" cy="740664"/>
+          </a:xfrm>
+          <a:prstGeom prst="rect">
+            <a:avLst/>
+          </a:prstGeom>
+          <a:noFill/>
+        </p:spPr>
+        <p:txBody>
+          <a:bodyPr wrap="square" lIns="0" rIns="0" tIns="0" bIns="0" anchor="t">
+            <a:spAutoFit/>
+          </a:bodyPr>
+          <a:lstStyle/>
+          <a:p>
             <a:pPr algn="l">
               <a:lnSpc>
-                <a:spcPct val="100000"/>
-              </a:lnSpc>
-              <a:spcBef>
-                <a:spcPts val="0"/>
-              </a:spcBef>
-              <a:spcAft>
-                <a:spcPts val="400"/>
-              </a:spcAft>
-            </a:pPr>
-            <a:r>
-              <a:rPr sz="1450" b="0">
-                <a:solidFill>
-                  <a:srgbClr val="D5DEE5"/>
+                <a:spcPct val="108000"/>
+              </a:lnSpc>
+            </a:pPr>
+            <a:r>
+              <a:rPr sz="1050" b="0">
+                <a:solidFill>
+                  <a:srgbClr val="5A6B78"/>
                 </a:solidFill>
                 <a:latin typeface="Segoe UI"/>
               </a:rPr>
-              <a:t>Role-based access with an immutable, verified audit trail</a:t>
-            </a:r>
-          </a:p>
-        </p:txBody>
-      </p:sp>
-      <p:sp>
-        <p:nvSpPr>
-          <p:cNvPr id="12" name="Oval 11"/>
+              <a:t>A single DATABASE_URL with automatic TLS runs on Render, Neon, Railway, Supabase or RDS — zero code change from local dev.</a:t>
+            </a:r>
+          </a:p>
+        </p:txBody>
+      </p:sp>
+      <p:sp>
+        <p:nvSpPr>
+          <p:cNvPr id="22" name="Rounded Rectangle 21"/>
           <p:cNvSpPr/>
           <p:nvPr/>
         </p:nvSpPr>
         <p:spPr>
           <a:xfrm>
-            <a:off x="822960" y="4453128"/>
-            <a:ext cx="146304" cy="146304"/>
-          </a:xfrm>
-          <a:prstGeom prst="ellipse">
+            <a:off x="502920" y="4343400"/>
+            <a:ext cx="5440680" cy="1700784"/>
+          </a:xfrm>
+          <a:prstGeom prst="roundRect">
+            <a:avLst>
+              <a:gd name="adj" fmla="val 5000"/>
+            </a:avLst>
+          </a:prstGeom>
+          <a:solidFill>
+            <a:srgbClr val="FFFFFF"/>
+          </a:solidFill>
+          <a:ln w="12700">
+            <a:solidFill>
+              <a:srgbClr val="D5DDE3"/>
+            </a:solidFill>
+          </a:ln>
+          <a:effectLst/>
+        </p:spPr>
+        <p:style>
+          <a:lnRef idx="1">
+            <a:schemeClr val="accent1"/>
+          </a:lnRef>
+          <a:fillRef idx="3">
+            <a:schemeClr val="accent1"/>
+          </a:fillRef>
+          <a:effectRef idx="2">
+            <a:schemeClr val="accent1"/>
+          </a:effectRef>
+          <a:fontRef idx="minor">
+            <a:schemeClr val="lt1"/>
+          </a:fontRef>
+        </p:style>
+        <p:txBody>
+          <a:bodyPr rtlCol="0" anchor="ctr"/>
+          <a:lstStyle/>
+          <a:p>
+            <a:pPr algn="ctr"/>
+          </a:p>
+        </p:txBody>
+      </p:sp>
+      <p:sp>
+        <p:nvSpPr>
+          <p:cNvPr id="23" name="Rectangle 22"/>
+          <p:cNvSpPr/>
+          <p:nvPr/>
+        </p:nvSpPr>
+        <p:spPr>
+          <a:xfrm>
+            <a:off x="502920" y="4343400"/>
+            <a:ext cx="5440680" cy="91440"/>
+          </a:xfrm>
+          <a:prstGeom prst="rect">
             <a:avLst/>
           </a:prstGeom>
           <a:solidFill>
@@ -20229,14 +20636,14 @@
       </p:sp>
       <p:sp>
         <p:nvSpPr>
-          <p:cNvPr id="13" name="TextBox 12"/>
+          <p:cNvPr id="24" name="TextBox 23"/>
           <p:cNvSpPr txBox="1"/>
           <p:nvPr/>
         </p:nvSpPr>
         <p:spPr>
           <a:xfrm>
-            <a:off x="1143000" y="4389120"/>
-            <a:ext cx="9601200" cy="457200"/>
+            <a:off x="777240" y="4581144"/>
+            <a:ext cx="4983480" cy="237744"/>
           </a:xfrm>
           <a:prstGeom prst="rect">
             <a:avLst/>
@@ -20244,50 +20651,162 @@
           <a:noFill/>
         </p:spPr>
         <p:txBody>
-          <a:bodyPr wrap="square" anchor="t" lIns="0" rIns="0" tIns="0" bIns="0">
+          <a:bodyPr wrap="square" lIns="0" rIns="0" tIns="0" bIns="0" anchor="t">
             <a:spAutoFit/>
           </a:bodyPr>
           <a:lstStyle/>
           <a:p>
+            <a:pPr algn="l"/>
+            <a:r>
+              <a:rPr sz="950" b="1">
+                <a:solidFill>
+                  <a:srgbClr val="E0912F"/>
+                </a:solidFill>
+                <a:latin typeface="Segoe UI"/>
+              </a:rPr>
+              <a:t>HARDENED</a:t>
+            </a:r>
+          </a:p>
+        </p:txBody>
+      </p:sp>
+      <p:sp>
+        <p:nvSpPr>
+          <p:cNvPr id="25" name="TextBox 24"/>
+          <p:cNvSpPr txBox="1"/>
+          <p:nvPr/>
+        </p:nvSpPr>
+        <p:spPr>
+          <a:xfrm>
+            <a:off x="777240" y="4837176"/>
+            <a:ext cx="4983480" cy="365760"/>
+          </a:xfrm>
+          <a:prstGeom prst="rect">
+            <a:avLst/>
+          </a:prstGeom>
+          <a:noFill/>
+        </p:spPr>
+        <p:txBody>
+          <a:bodyPr wrap="square" lIns="0" rIns="0" tIns="0" bIns="0" anchor="t">
+            <a:spAutoFit/>
+          </a:bodyPr>
+          <a:lstStyle/>
+          <a:p>
+            <a:pPr algn="l"/>
+            <a:r>
+              <a:rPr sz="1500" b="1">
+                <a:solidFill>
+                  <a:srgbClr val="112A40"/>
+                </a:solidFill>
+                <a:latin typeface="Segoe UI Semibold"/>
+              </a:rPr>
+              <a:t>Production-ready by default</a:t>
+            </a:r>
+          </a:p>
+        </p:txBody>
+      </p:sp>
+      <p:sp>
+        <p:nvSpPr>
+          <p:cNvPr id="26" name="TextBox 25"/>
+          <p:cNvSpPr txBox="1"/>
+          <p:nvPr/>
+        </p:nvSpPr>
+        <p:spPr>
+          <a:xfrm>
+            <a:off x="777240" y="5239512"/>
+            <a:ext cx="4937760" cy="740664"/>
+          </a:xfrm>
+          <a:prstGeom prst="rect">
+            <a:avLst/>
+          </a:prstGeom>
+          <a:noFill/>
+        </p:spPr>
+        <p:txBody>
+          <a:bodyPr wrap="square" lIns="0" rIns="0" tIns="0" bIns="0" anchor="t">
+            <a:spAutoFit/>
+          </a:bodyPr>
+          <a:lstStyle/>
+          <a:p>
             <a:pPr algn="l">
               <a:lnSpc>
-                <a:spcPct val="100000"/>
-              </a:lnSpc>
-              <a:spcBef>
-                <a:spcPts val="0"/>
-              </a:spcBef>
-              <a:spcAft>
-                <a:spcPts val="400"/>
-              </a:spcAft>
-            </a:pPr>
-            <a:r>
-              <a:rPr sz="1450" b="0">
-                <a:solidFill>
-                  <a:srgbClr val="D5DEE5"/>
+                <a:spcPct val="108000"/>
+              </a:lnSpc>
+            </a:pPr>
+            <a:r>
+              <a:rPr sz="1050" b="0">
+                <a:solidFill>
+                  <a:srgbClr val="5A6B78"/>
                 </a:solidFill>
                 <a:latin typeface="Segoe UI"/>
               </a:rPr>
-              <a:t>Verified end-to-end — 32 tests plus a live run to closure</a:t>
-            </a:r>
-          </a:p>
-        </p:txBody>
-      </p:sp>
-      <p:sp>
-        <p:nvSpPr>
-          <p:cNvPr id="14" name="Rectangle 13"/>
+              <a:t>Secure cookies, HSTS, HTTPS-only, a boot check that refuses a weak JWT secret, and one-time rotation of every seeded password.</a:t>
+            </a:r>
+          </a:p>
+        </p:txBody>
+      </p:sp>
+      <p:sp>
+        <p:nvSpPr>
+          <p:cNvPr id="27" name="Rounded Rectangle 26"/>
           <p:cNvSpPr/>
           <p:nvPr/>
         </p:nvSpPr>
         <p:spPr>
           <a:xfrm>
-            <a:off x="822960" y="5257800"/>
-            <a:ext cx="3840480" cy="18288"/>
-          </a:xfrm>
-          <a:prstGeom prst="rect">
-            <a:avLst/>
+            <a:off x="6254496" y="4343400"/>
+            <a:ext cx="5440680" cy="1700784"/>
+          </a:xfrm>
+          <a:prstGeom prst="roundRect">
+            <a:avLst>
+              <a:gd name="adj" fmla="val 5000"/>
+            </a:avLst>
           </a:prstGeom>
           <a:solidFill>
-            <a:srgbClr val="3A5369"/>
+            <a:srgbClr val="FFFFFF"/>
+          </a:solidFill>
+          <a:ln w="12700">
+            <a:solidFill>
+              <a:srgbClr val="D5DDE3"/>
+            </a:solidFill>
+          </a:ln>
+          <a:effectLst/>
+        </p:spPr>
+        <p:style>
+          <a:lnRef idx="1">
+            <a:schemeClr val="accent1"/>
+          </a:lnRef>
+          <a:fillRef idx="3">
+            <a:schemeClr val="accent1"/>
+          </a:fillRef>
+          <a:effectRef idx="2">
+            <a:schemeClr val="accent1"/>
+          </a:effectRef>
+          <a:fontRef idx="minor">
+            <a:schemeClr val="lt1"/>
+          </a:fontRef>
+        </p:style>
+        <p:txBody>
+          <a:bodyPr rtlCol="0" anchor="ctr"/>
+          <a:lstStyle/>
+          <a:p>
+            <a:pPr algn="ctr"/>
+          </a:p>
+        </p:txBody>
+      </p:sp>
+      <p:sp>
+        <p:nvSpPr>
+          <p:cNvPr id="28" name="Rectangle 27"/>
+          <p:cNvSpPr/>
+          <p:nvPr/>
+        </p:nvSpPr>
+        <p:spPr>
+          <a:xfrm>
+            <a:off x="6254496" y="4343400"/>
+            <a:ext cx="5440680" cy="91440"/>
+          </a:xfrm>
+          <a:prstGeom prst="rect">
+            <a:avLst/>
+          </a:prstGeom>
+          <a:solidFill>
+            <a:srgbClr val="E0912F"/>
           </a:solidFill>
           <a:ln>
             <a:noFill/>
@@ -20318,14 +20837,14 @@
       </p:sp>
       <p:sp>
         <p:nvSpPr>
-          <p:cNvPr id="15" name="TextBox 14"/>
+          <p:cNvPr id="29" name="TextBox 28"/>
           <p:cNvSpPr txBox="1"/>
           <p:nvPr/>
         </p:nvSpPr>
         <p:spPr>
           <a:xfrm>
-            <a:off x="822960" y="5486400"/>
-            <a:ext cx="10058400" cy="914400"/>
+            <a:off x="6528816" y="4581144"/>
+            <a:ext cx="4983480" cy="237744"/>
           </a:xfrm>
           <a:prstGeom prst="rect">
             <a:avLst/>
@@ -20333,154 +20852,34 @@
           <a:noFill/>
         </p:spPr>
         <p:txBody>
-          <a:bodyPr wrap="square" anchor="t" lIns="0" rIns="0" tIns="0" bIns="0">
+          <a:bodyPr wrap="square" lIns="0" rIns="0" tIns="0" bIns="0" anchor="t">
             <a:spAutoFit/>
           </a:bodyPr>
           <a:lstStyle/>
           <a:p>
-            <a:pPr algn="l">
-              <a:lnSpc>
-                <a:spcPct val="100000"/>
-              </a:lnSpc>
-              <a:spcBef>
-                <a:spcPts val="0"/>
-              </a:spcBef>
-              <a:spcAft>
-                <a:spcPts val="400"/>
-              </a:spcAft>
-            </a:pPr>
-            <a:r>
-              <a:rPr sz="2200" b="1">
-                <a:solidFill>
-                  <a:srgbClr val="FFFFFF"/>
-                </a:solidFill>
-                <a:latin typeface="Segoe UI Semibold"/>
-              </a:rPr>
-              <a:t>Thank you</a:t>
-            </a:r>
-          </a:p>
-          <a:p>
-            <a:pPr algn="l">
-              <a:lnSpc>
-                <a:spcPct val="100000"/>
-              </a:lnSpc>
-              <a:spcBef>
-                <a:spcPts val="0"/>
-              </a:spcBef>
-              <a:spcAft>
-                <a:spcPts val="400"/>
-              </a:spcAft>
-            </a:pPr>
-            <a:r>
-              <a:rPr sz="1250" b="0">
-                <a:solidFill>
-                  <a:srgbClr val="B9C7D2"/>
+            <a:pPr algn="l"/>
+            <a:r>
+              <a:rPr sz="950" b="1">
+                <a:solidFill>
+                  <a:srgbClr val="E0912F"/>
                 </a:solidFill>
                 <a:latin typeface="Segoe UI"/>
               </a:rPr>
-              <a:t>Keshav Raj Jain   ·   Orient Paper &amp; Mill — CCMS</a:t>
-            </a:r>
-          </a:p>
-        </p:txBody>
-      </p:sp>
-      <p:sp>
-        <p:nvSpPr>
-          <p:cNvPr id="16" name="Rectangle 15"/>
-          <p:cNvSpPr/>
-          <p:nvPr/>
-        </p:nvSpPr>
-        <p:spPr>
-          <a:xfrm>
-            <a:off x="9509760" y="0"/>
-            <a:ext cx="2681935" cy="6858000"/>
-          </a:xfrm>
-          <a:prstGeom prst="rect">
-            <a:avLst/>
-          </a:prstGeom>
-          <a:solidFill>
-            <a:srgbClr val="1B3A55"/>
-          </a:solidFill>
-          <a:ln>
-            <a:noFill/>
-          </a:ln>
-          <a:effectLst/>
-        </p:spPr>
-        <p:style>
-          <a:lnRef idx="1">
-            <a:schemeClr val="accent1"/>
-          </a:lnRef>
-          <a:fillRef idx="3">
-            <a:schemeClr val="accent1"/>
-          </a:fillRef>
-          <a:effectRef idx="2">
-            <a:schemeClr val="accent1"/>
-          </a:effectRef>
-          <a:fontRef idx="minor">
-            <a:schemeClr val="lt1"/>
-          </a:fontRef>
-        </p:style>
-        <p:txBody>
-          <a:bodyPr rtlCol="0" anchor="ctr"/>
-          <a:lstStyle/>
-          <a:p>
-            <a:pPr algn="ctr"/>
-          </a:p>
-        </p:txBody>
-      </p:sp>
-      <p:sp>
-        <p:nvSpPr>
-          <p:cNvPr id="17" name="Rectangle 16"/>
-          <p:cNvSpPr/>
-          <p:nvPr/>
-        </p:nvSpPr>
-        <p:spPr>
-          <a:xfrm>
-            <a:off x="9509760" y="0"/>
-            <a:ext cx="54864" cy="6858000"/>
-          </a:xfrm>
-          <a:prstGeom prst="rect">
-            <a:avLst/>
-          </a:prstGeom>
-          <a:solidFill>
-            <a:srgbClr val="1F8A80"/>
-          </a:solidFill>
-          <a:ln>
-            <a:noFill/>
-          </a:ln>
-          <a:effectLst/>
-        </p:spPr>
-        <p:style>
-          <a:lnRef idx="1">
-            <a:schemeClr val="accent1"/>
-          </a:lnRef>
-          <a:fillRef idx="3">
-            <a:schemeClr val="accent1"/>
-          </a:fillRef>
-          <a:effectRef idx="2">
-            <a:schemeClr val="accent1"/>
-          </a:effectRef>
-          <a:fontRef idx="minor">
-            <a:schemeClr val="lt1"/>
-          </a:fontRef>
-        </p:style>
-        <p:txBody>
-          <a:bodyPr rtlCol="0" anchor="ctr"/>
-          <a:lstStyle/>
-          <a:p>
-            <a:pPr algn="ctr"/>
-          </a:p>
-        </p:txBody>
-      </p:sp>
-      <p:sp>
-        <p:nvSpPr>
-          <p:cNvPr id="18" name="TextBox 17"/>
+              <a:t>EMAIL</a:t>
+            </a:r>
+          </a:p>
+        </p:txBody>
+      </p:sp>
+      <p:sp>
+        <p:nvSpPr>
+          <p:cNvPr id="30" name="TextBox 29"/>
           <p:cNvSpPr txBox="1"/>
           <p:nvPr/>
         </p:nvSpPr>
         <p:spPr>
           <a:xfrm>
-            <a:off x="9829800" y="2286000"/>
-            <a:ext cx="2194560" cy="2286000"/>
+            <a:off x="6528816" y="4837176"/>
+            <a:ext cx="4983480" cy="365760"/>
           </a:xfrm>
           <a:prstGeom prst="rect">
             <a:avLst/>
@@ -20488,96 +20887,59 @@
           <a:noFill/>
         </p:spPr>
         <p:txBody>
-          <a:bodyPr wrap="square" anchor="ctr" lIns="0" rIns="0" tIns="0" bIns="0">
+          <a:bodyPr wrap="square" lIns="0" rIns="0" tIns="0" bIns="0" anchor="t">
             <a:spAutoFit/>
           </a:bodyPr>
           <a:lstStyle/>
           <a:p>
+            <a:pPr algn="l"/>
+            <a:r>
+              <a:rPr sz="1500" b="1">
+                <a:solidFill>
+                  <a:srgbClr val="112A40"/>
+                </a:solidFill>
+                <a:latin typeface="Segoe UI Semibold"/>
+              </a:rPr>
+              <a:t>Real inbox delivery</a:t>
+            </a:r>
+          </a:p>
+        </p:txBody>
+      </p:sp>
+      <p:sp>
+        <p:nvSpPr>
+          <p:cNvPr id="31" name="TextBox 30"/>
+          <p:cNvSpPr txBox="1"/>
+          <p:nvPr/>
+        </p:nvSpPr>
+        <p:spPr>
+          <a:xfrm>
+            <a:off x="6528816" y="5239512"/>
+            <a:ext cx="4937760" cy="740664"/>
+          </a:xfrm>
+          <a:prstGeom prst="rect">
+            <a:avLst/>
+          </a:prstGeom>
+          <a:noFill/>
+        </p:spPr>
+        <p:txBody>
+          <a:bodyPr wrap="square" lIns="0" rIns="0" tIns="0" bIns="0" anchor="t">
+            <a:spAutoFit/>
+          </a:bodyPr>
+          <a:lstStyle/>
+          <a:p>
             <a:pPr algn="l">
               <a:lnSpc>
-                <a:spcPct val="100000"/>
-              </a:lnSpc>
-              <a:spcBef>
-                <a:spcPts val="0"/>
-              </a:spcBef>
-              <a:spcAft>
-                <a:spcPts val="200"/>
-              </a:spcAft>
-            </a:pPr>
-            <a:r>
-              <a:rPr sz="3000" b="1">
-                <a:solidFill>
-                  <a:srgbClr val="FFFFFF"/>
-                </a:solidFill>
-                <a:latin typeface="Segoe UI Semibold"/>
-              </a:rPr>
-              <a:t>Q &amp; A</a:t>
-            </a:r>
-          </a:p>
-          <a:p>
-            <a:pPr algn="l">
-              <a:lnSpc>
-                <a:spcPct val="100000"/>
-              </a:lnSpc>
-              <a:spcBef>
-                <a:spcPts val="0"/>
-              </a:spcBef>
-              <a:spcAft>
-                <a:spcPts val="200"/>
-              </a:spcAft>
-            </a:pPr>
-            <a:r>
-              <a:rPr sz="1000" b="0">
-                <a:solidFill>
-                  <a:srgbClr val="FFFFFF"/>
+                <a:spcPct val="108000"/>
+              </a:lnSpc>
+            </a:pPr>
+            <a:r>
+              <a:rPr sz="1050" b="0">
+                <a:solidFill>
+                  <a:srgbClr val="5A6B78"/>
                 </a:solidFill>
                 <a:latin typeface="Segoe UI"/>
               </a:rPr>
-              <a:t> </a:t>
-            </a:r>
-          </a:p>
-          <a:p>
-            <a:pPr algn="l">
-              <a:lnSpc>
-                <a:spcPct val="100000"/>
-              </a:lnSpc>
-              <a:spcBef>
-                <a:spcPts val="0"/>
-              </a:spcBef>
-              <a:spcAft>
-                <a:spcPts val="200"/>
-              </a:spcAft>
-            </a:pPr>
-            <a:r>
-              <a:rPr sz="1300" b="1">
-                <a:solidFill>
-                  <a:srgbClr val="E0912F"/>
-                </a:solidFill>
-                <a:latin typeface="Segoe UI"/>
-              </a:rPr>
-              <a:t>Questions</a:t>
-            </a:r>
-          </a:p>
-          <a:p>
-            <a:pPr algn="l">
-              <a:lnSpc>
-                <a:spcPct val="100000"/>
-              </a:lnSpc>
-              <a:spcBef>
-                <a:spcPts val="0"/>
-              </a:spcBef>
-              <a:spcAft>
-                <a:spcPts val="200"/>
-              </a:spcAft>
-            </a:pPr>
-            <a:r>
-              <a:rPr sz="1300" b="1">
-                <a:solidFill>
-                  <a:srgbClr val="E0912F"/>
-                </a:solidFill>
-                <a:latin typeface="Segoe UI"/>
-              </a:rPr>
-              <a:t>welcome</a:t>
+              <a:t>Customer and staff notifications go out over SMTP (Gmail / Brevo / any relay) and are mirrored to the in-app Emails trail.</a:t>
             </a:r>
           </a:p>
         </p:txBody>
@@ -23150,7 +23512,7 @@
         <p:spPr>
           <a:xfrm>
             <a:off x="0" y="0"/>
-            <a:ext cx="12191695" cy="1170432"/>
+            <a:ext cx="12191695" cy="6858000"/>
           </a:xfrm>
           <a:prstGeom prst="rect">
             <a:avLst/>
@@ -23193,8 +23555,8 @@
         </p:nvSpPr>
         <p:spPr>
           <a:xfrm>
-            <a:off x="0" y="1170432"/>
-            <a:ext cx="12191695" cy="54864"/>
+            <a:off x="0" y="0"/>
+            <a:ext cx="256032" cy="6858000"/>
           </a:xfrm>
           <a:prstGeom prst="rect">
             <a:avLst/>
@@ -23237,8 +23599,8 @@
         </p:nvSpPr>
         <p:spPr>
           <a:xfrm>
-            <a:off x="502920" y="219456"/>
-            <a:ext cx="10058400" cy="274320"/>
+            <a:off x="822960" y="1005840"/>
+            <a:ext cx="10058400" cy="457200"/>
           </a:xfrm>
           <a:prstGeom prst="rect">
             <a:avLst/>
@@ -23246,20 +23608,30 @@
           <a:noFill/>
         </p:spPr>
         <p:txBody>
-          <a:bodyPr wrap="square" lIns="0" rIns="0" tIns="0" bIns="0" anchor="t">
+          <a:bodyPr wrap="square" anchor="t" lIns="0" rIns="0" tIns="0" bIns="0">
             <a:spAutoFit/>
           </a:bodyPr>
           <a:lstStyle/>
           <a:p>
-            <a:pPr algn="l"/>
-            <a:r>
-              <a:rPr sz="1100" b="1">
+            <a:pPr algn="l">
+              <a:lnSpc>
+                <a:spcPct val="100000"/>
+              </a:lnSpc>
+              <a:spcBef>
+                <a:spcPts val="0"/>
+              </a:spcBef>
+              <a:spcAft>
+                <a:spcPts val="400"/>
+              </a:spcAft>
+            </a:pPr>
+            <a:r>
+              <a:rPr sz="1300" b="1">
                 <a:solidFill>
                   <a:srgbClr val="E0912F"/>
                 </a:solidFill>
                 <a:latin typeface="Segoe UI"/>
               </a:rPr>
-              <a:t>09 · DEPLOYMENT</a:t>
+              <a:t>CONCLUSION</a:t>
             </a:r>
           </a:p>
         </p:txBody>
@@ -23272,8 +23644,8 @@
         </p:nvSpPr>
         <p:spPr>
           <a:xfrm>
-            <a:off x="502920" y="457200"/>
-            <a:ext cx="11155680" cy="640080"/>
+            <a:off x="777240" y="1371600"/>
+            <a:ext cx="10607040" cy="1371600"/>
           </a:xfrm>
           <a:prstGeom prst="rect">
             <a:avLst/>
@@ -23281,199 +23653,69 @@
           <a:noFill/>
         </p:spPr>
         <p:txBody>
-          <a:bodyPr wrap="square" lIns="0" rIns="0" tIns="0" bIns="0" anchor="t">
+          <a:bodyPr wrap="square" anchor="t" lIns="0" rIns="0" tIns="0" bIns="0">
             <a:spAutoFit/>
           </a:bodyPr>
           <a:lstStyle/>
           <a:p>
-            <a:pPr algn="l"/>
-            <a:r>
-              <a:rPr sz="2600" b="1">
+            <a:pPr algn="l">
+              <a:lnSpc>
+                <a:spcPct val="100000"/>
+              </a:lnSpc>
+              <a:spcBef>
+                <a:spcPts val="0"/>
+              </a:spcBef>
+              <a:spcAft>
+                <a:spcPts val="200"/>
+              </a:spcAft>
+            </a:pPr>
+            <a:r>
+              <a:rPr sz="3400" b="1">
                 <a:solidFill>
                   <a:srgbClr val="FFFFFF"/>
                 </a:solidFill>
                 <a:latin typeface="Segoe UI Semibold"/>
               </a:rPr>
-              <a:t>Deployed live on the internet</a:t>
-            </a:r>
-          </a:p>
-        </p:txBody>
-      </p:sp>
-      <p:sp>
-        <p:nvSpPr>
-          <p:cNvPr id="6" name="Rectangle 5"/>
+              <a:t>A complete, governed, SAP-ready</a:t>
+            </a:r>
+          </a:p>
+          <a:p>
+            <a:pPr algn="l">
+              <a:lnSpc>
+                <a:spcPct val="100000"/>
+              </a:lnSpc>
+              <a:spcBef>
+                <a:spcPts val="0"/>
+              </a:spcBef>
+              <a:spcAft>
+                <a:spcPts val="200"/>
+              </a:spcAft>
+            </a:pPr>
+            <a:r>
+              <a:rPr sz="3400" b="1">
+                <a:solidFill>
+                  <a:srgbClr val="FFFFFF"/>
+                </a:solidFill>
+                <a:latin typeface="Segoe UI Semibold"/>
+              </a:rPr>
+              <a:t>complaint management platform.</a:t>
+            </a:r>
+          </a:p>
+        </p:txBody>
+      </p:sp>
+      <p:sp>
+        <p:nvSpPr>
+          <p:cNvPr id="6" name="Oval 5"/>
           <p:cNvSpPr/>
           <p:nvPr/>
         </p:nvSpPr>
         <p:spPr>
           <a:xfrm>
-            <a:off x="0" y="6510528"/>
-            <a:ext cx="12191695" cy="347472"/>
-          </a:xfrm>
-          <a:prstGeom prst="rect">
-            <a:avLst/>
-          </a:prstGeom>
-          <a:solidFill>
-            <a:srgbClr val="112A40"/>
-          </a:solidFill>
-          <a:ln>
-            <a:noFill/>
-          </a:ln>
-          <a:effectLst/>
-        </p:spPr>
-        <p:style>
-          <a:lnRef idx="1">
-            <a:schemeClr val="accent1"/>
-          </a:lnRef>
-          <a:fillRef idx="3">
-            <a:schemeClr val="accent1"/>
-          </a:fillRef>
-          <a:effectRef idx="2">
-            <a:schemeClr val="accent1"/>
-          </a:effectRef>
-          <a:fontRef idx="minor">
-            <a:schemeClr val="lt1"/>
-          </a:fontRef>
-        </p:style>
-        <p:txBody>
-          <a:bodyPr rtlCol="0" anchor="ctr"/>
-          <a:lstStyle/>
-          <a:p>
-            <a:pPr algn="ctr"/>
-          </a:p>
-        </p:txBody>
-      </p:sp>
-      <p:sp>
-        <p:nvSpPr>
-          <p:cNvPr id="7" name="TextBox 6"/>
-          <p:cNvSpPr txBox="1"/>
-          <p:nvPr/>
-        </p:nvSpPr>
-        <p:spPr>
-          <a:xfrm>
-            <a:off x="502920" y="6528816"/>
-            <a:ext cx="7315200" cy="310896"/>
-          </a:xfrm>
-          <a:prstGeom prst="rect">
-            <a:avLst/>
-          </a:prstGeom>
-          <a:noFill/>
-        </p:spPr>
-        <p:txBody>
-          <a:bodyPr wrap="square" lIns="0" rIns="0" tIns="0" bIns="0" anchor="t">
-            <a:spAutoFit/>
-          </a:bodyPr>
-          <a:lstStyle/>
-          <a:p>
-            <a:pPr algn="l"/>
-            <a:r>
-              <a:rPr sz="900" b="0">
-                <a:solidFill>
-                  <a:srgbClr val="B9C7D2"/>
-                </a:solidFill>
-                <a:latin typeface="Segoe UI"/>
-              </a:rPr>
-              <a:t>Customer Complaint Management System  ·  Orient Paper &amp; Mill</a:t>
-            </a:r>
-          </a:p>
-        </p:txBody>
-      </p:sp>
-      <p:sp>
-        <p:nvSpPr>
-          <p:cNvPr id="8" name="TextBox 7"/>
-          <p:cNvSpPr txBox="1"/>
-          <p:nvPr/>
-        </p:nvSpPr>
-        <p:spPr>
-          <a:xfrm>
-            <a:off x="10424160" y="6528816"/>
-            <a:ext cx="1280160" cy="310896"/>
-          </a:xfrm>
-          <a:prstGeom prst="rect">
-            <a:avLst/>
-          </a:prstGeom>
-          <a:noFill/>
-        </p:spPr>
-        <p:txBody>
-          <a:bodyPr wrap="square" lIns="0" rIns="0" tIns="0" bIns="0" anchor="t">
-            <a:spAutoFit/>
-          </a:bodyPr>
-          <a:lstStyle/>
-          <a:p>
-            <a:pPr algn="r"/>
-            <a:r>
-              <a:rPr sz="900" b="1">
-                <a:solidFill>
-                  <a:srgbClr val="E0912F"/>
-                </a:solidFill>
-                <a:latin typeface="Segoe UI"/>
-              </a:rPr>
-              <a:t>18</a:t>
-            </a:r>
-          </a:p>
-        </p:txBody>
-      </p:sp>
-      <p:sp>
-        <p:nvSpPr>
-          <p:cNvPr id="9" name="Rounded Rectangle 8"/>
-          <p:cNvSpPr/>
-          <p:nvPr/>
-        </p:nvSpPr>
-        <p:spPr>
-          <a:xfrm>
-            <a:off x="502920" y="1463040"/>
-            <a:ext cx="11183112" cy="841248"/>
-          </a:xfrm>
-          <a:prstGeom prst="roundRect">
-            <a:avLst>
-              <a:gd name="adj" fmla="val 10000"/>
-            </a:avLst>
-          </a:prstGeom>
-          <a:solidFill>
-            <a:srgbClr val="EEF2F5"/>
-          </a:solidFill>
-          <a:ln>
-            <a:noFill/>
-          </a:ln>
-          <a:effectLst/>
-        </p:spPr>
-        <p:style>
-          <a:lnRef idx="1">
-            <a:schemeClr val="accent1"/>
-          </a:lnRef>
-          <a:fillRef idx="3">
-            <a:schemeClr val="accent1"/>
-          </a:fillRef>
-          <a:effectRef idx="2">
-            <a:schemeClr val="accent1"/>
-          </a:effectRef>
-          <a:fontRef idx="minor">
-            <a:schemeClr val="lt1"/>
-          </a:fontRef>
-        </p:style>
-        <p:txBody>
-          <a:bodyPr rtlCol="0" anchor="ctr"/>
-          <a:lstStyle/>
-          <a:p>
-            <a:pPr algn="ctr"/>
-          </a:p>
-        </p:txBody>
-      </p:sp>
-      <p:sp>
-        <p:nvSpPr>
-          <p:cNvPr id="10" name="Rounded Rectangle 9"/>
-          <p:cNvSpPr/>
-          <p:nvPr/>
-        </p:nvSpPr>
-        <p:spPr>
-          <a:xfrm>
-            <a:off x="713232" y="1609344"/>
-            <a:ext cx="118872" cy="548640"/>
-          </a:xfrm>
-          <a:prstGeom prst="roundRect">
-            <a:avLst>
-              <a:gd name="adj" fmla="val 50000"/>
-            </a:avLst>
+            <a:off x="822960" y="2944368"/>
+            <a:ext cx="146304" cy="146304"/>
+          </a:xfrm>
+          <a:prstGeom prst="ellipse">
+            <a:avLst/>
           </a:prstGeom>
           <a:solidFill>
             <a:srgbClr val="E0912F"/>
@@ -23507,14 +23749,14 @@
       </p:sp>
       <p:sp>
         <p:nvSpPr>
-          <p:cNvPr id="11" name="TextBox 10"/>
+          <p:cNvPr id="7" name="TextBox 6"/>
           <p:cNvSpPr txBox="1"/>
           <p:nvPr/>
         </p:nvSpPr>
         <p:spPr>
           <a:xfrm>
-            <a:off x="969264" y="1463040"/>
-            <a:ext cx="10424160" cy="841248"/>
+            <a:off x="1143000" y="2880360"/>
+            <a:ext cx="9601200" cy="457200"/>
           </a:xfrm>
           <a:prstGeom prst="rect">
             <a:avLst/>
@@ -23522,109 +23764,46 @@
           <a:noFill/>
         </p:spPr>
         <p:txBody>
-          <a:bodyPr wrap="square" lIns="0" rIns="0" tIns="0" bIns="0" anchor="ctr">
+          <a:bodyPr wrap="square" anchor="t" lIns="0" rIns="0" tIns="0" bIns="0">
             <a:spAutoFit/>
           </a:bodyPr>
           <a:lstStyle/>
           <a:p>
-            <a:pPr algn="l"/>
-            <a:r>
-              <a:rPr sz="1300" b="0">
-                <a:solidFill>
-                  <a:srgbClr val="1A2530"/>
+            <a:pPr algn="l">
+              <a:lnSpc>
+                <a:spcPct val="100000"/>
+              </a:lnSpc>
+              <a:spcBef>
+                <a:spcPts val="0"/>
+              </a:spcBef>
+              <a:spcAft>
+                <a:spcPts val="400"/>
+              </a:spcAft>
+            </a:pPr>
+            <a:r>
+              <a:rPr sz="1450" b="0">
+                <a:solidFill>
+                  <a:srgbClr val="D5DEE5"/>
                 </a:solidFill>
                 <a:latin typeface="Segoe UI"/>
               </a:rPr>
-              <a:t>Live at  </a:t>
-            </a:r>
-            <a:r>
-              <a:rPr sz="1400" b="1">
-                <a:solidFill>
-                  <a:srgbClr val="112A40"/>
-                </a:solidFill>
-                <a:latin typeface="Segoe UI Semibold"/>
-              </a:rPr>
-              <a:t>https://ccms-6dut.onrender.com</a:t>
-            </a:r>
-          </a:p>
-          <a:p>
-            <a:pPr algn="l">
-              <a:spcAft>
-                <a:spcPts val="0"/>
-              </a:spcAft>
-            </a:pPr>
-            <a:r>
-              <a:rPr sz="1100" b="0">
-                <a:solidFill>
-                  <a:srgbClr val="5A6B78"/>
-                </a:solidFill>
-                <a:latin typeface="Segoe UI"/>
-              </a:rPr>
-              <a:t>Deployed as a single web service on managed PostgreSQL, with production security enabled.</a:t>
-            </a:r>
-          </a:p>
-        </p:txBody>
-      </p:sp>
-      <p:sp>
-        <p:nvSpPr>
-          <p:cNvPr id="12" name="Rounded Rectangle 11"/>
+              <a:t>Full 8-stage lifecycle with automated approval gates</a:t>
+            </a:r>
+          </a:p>
+        </p:txBody>
+      </p:sp>
+      <p:sp>
+        <p:nvSpPr>
+          <p:cNvPr id="8" name="Oval 7"/>
           <p:cNvSpPr/>
           <p:nvPr/>
         </p:nvSpPr>
         <p:spPr>
           <a:xfrm>
-            <a:off x="502920" y="2514600"/>
-            <a:ext cx="5440680" cy="1700784"/>
-          </a:xfrm>
-          <a:prstGeom prst="roundRect">
-            <a:avLst>
-              <a:gd name="adj" fmla="val 5000"/>
-            </a:avLst>
-          </a:prstGeom>
-          <a:solidFill>
-            <a:srgbClr val="FFFFFF"/>
-          </a:solidFill>
-          <a:ln w="12700">
-            <a:solidFill>
-              <a:srgbClr val="D5DDE3"/>
-            </a:solidFill>
-          </a:ln>
-          <a:effectLst/>
-        </p:spPr>
-        <p:style>
-          <a:lnRef idx="1">
-            <a:schemeClr val="accent1"/>
-          </a:lnRef>
-          <a:fillRef idx="3">
-            <a:schemeClr val="accent1"/>
-          </a:fillRef>
-          <a:effectRef idx="2">
-            <a:schemeClr val="accent1"/>
-          </a:effectRef>
-          <a:fontRef idx="minor">
-            <a:schemeClr val="lt1"/>
-          </a:fontRef>
-        </p:style>
-        <p:txBody>
-          <a:bodyPr rtlCol="0" anchor="ctr"/>
-          <a:lstStyle/>
-          <a:p>
-            <a:pPr algn="ctr"/>
-          </a:p>
-        </p:txBody>
-      </p:sp>
-      <p:sp>
-        <p:nvSpPr>
-          <p:cNvPr id="13" name="Rectangle 12"/>
-          <p:cNvSpPr/>
-          <p:nvPr/>
-        </p:nvSpPr>
-        <p:spPr>
-          <a:xfrm>
-            <a:off x="502920" y="2514600"/>
-            <a:ext cx="5440680" cy="91440"/>
-          </a:xfrm>
-          <a:prstGeom prst="rect">
+            <a:off x="822960" y="3447288"/>
+            <a:ext cx="146304" cy="146304"/>
+          </a:xfrm>
+          <a:prstGeom prst="ellipse">
             <a:avLst/>
           </a:prstGeom>
           <a:solidFill>
@@ -23659,14 +23838,14 @@
       </p:sp>
       <p:sp>
         <p:nvSpPr>
-          <p:cNvPr id="14" name="TextBox 13"/>
+          <p:cNvPr id="9" name="TextBox 8"/>
           <p:cNvSpPr txBox="1"/>
           <p:nvPr/>
         </p:nvSpPr>
         <p:spPr>
           <a:xfrm>
-            <a:off x="777240" y="2752344"/>
-            <a:ext cx="4983480" cy="237744"/>
+            <a:off x="1143000" y="3383280"/>
+            <a:ext cx="9601200" cy="457200"/>
           </a:xfrm>
           <a:prstGeom prst="rect">
             <a:avLst/>
@@ -23674,158 +23853,46 @@
           <a:noFill/>
         </p:spPr>
         <p:txBody>
-          <a:bodyPr wrap="square" lIns="0" rIns="0" tIns="0" bIns="0" anchor="t">
+          <a:bodyPr wrap="square" anchor="t" lIns="0" rIns="0" tIns="0" bIns="0">
             <a:spAutoFit/>
           </a:bodyPr>
           <a:lstStyle/>
           <a:p>
-            <a:pPr algn="l"/>
-            <a:r>
-              <a:rPr sz="950" b="1">
-                <a:solidFill>
-                  <a:srgbClr val="E0912F"/>
+            <a:pPr algn="l">
+              <a:lnSpc>
+                <a:spcPct val="100000"/>
+              </a:lnSpc>
+              <a:spcBef>
+                <a:spcPts val="0"/>
+              </a:spcBef>
+              <a:spcAft>
+                <a:spcPts val="400"/>
+              </a:spcAft>
+            </a:pPr>
+            <a:r>
+              <a:rPr sz="1450" b="0">
+                <a:solidFill>
+                  <a:srgbClr val="D5DEE5"/>
                 </a:solidFill>
                 <a:latin typeface="Segoe UI"/>
               </a:rPr>
-              <a:t>ARCHITECTURE</a:t>
-            </a:r>
-          </a:p>
-        </p:txBody>
-      </p:sp>
-      <p:sp>
-        <p:nvSpPr>
-          <p:cNvPr id="15" name="TextBox 14"/>
-          <p:cNvSpPr txBox="1"/>
-          <p:nvPr/>
-        </p:nvSpPr>
-        <p:spPr>
-          <a:xfrm>
-            <a:off x="777240" y="3008376"/>
-            <a:ext cx="4983480" cy="365760"/>
-          </a:xfrm>
-          <a:prstGeom prst="rect">
-            <a:avLst/>
-          </a:prstGeom>
-          <a:noFill/>
-        </p:spPr>
-        <p:txBody>
-          <a:bodyPr wrap="square" lIns="0" rIns="0" tIns="0" bIns="0" anchor="t">
-            <a:spAutoFit/>
-          </a:bodyPr>
-          <a:lstStyle/>
-          <a:p>
-            <a:pPr algn="l"/>
-            <a:r>
-              <a:rPr sz="1500" b="1">
-                <a:solidFill>
-                  <a:srgbClr val="112A40"/>
-                </a:solidFill>
-                <a:latin typeface="Segoe UI Semibold"/>
-              </a:rPr>
-              <a:t>One service, one origin</a:t>
-            </a:r>
-          </a:p>
-        </p:txBody>
-      </p:sp>
-      <p:sp>
-        <p:nvSpPr>
-          <p:cNvPr id="16" name="TextBox 15"/>
-          <p:cNvSpPr txBox="1"/>
-          <p:nvPr/>
-        </p:nvSpPr>
-        <p:spPr>
-          <a:xfrm>
-            <a:off x="777240" y="3410712"/>
-            <a:ext cx="4937760" cy="740664"/>
-          </a:xfrm>
-          <a:prstGeom prst="rect">
-            <a:avLst/>
-          </a:prstGeom>
-          <a:noFill/>
-        </p:spPr>
-        <p:txBody>
-          <a:bodyPr wrap="square" lIns="0" rIns="0" tIns="0" bIns="0" anchor="t">
-            <a:spAutoFit/>
-          </a:bodyPr>
-          <a:lstStyle/>
-          <a:p>
-            <a:pPr algn="l">
-              <a:lnSpc>
-                <a:spcPct val="108000"/>
-              </a:lnSpc>
-            </a:pPr>
-            <a:r>
-              <a:rPr sz="1050" b="0">
-                <a:solidFill>
-                  <a:srgbClr val="5A6B78"/>
-                </a:solidFill>
-                <a:latin typeface="Segoe UI"/>
-              </a:rPr>
-              <a:t>The Express API also serves the SPA — a single origin, so no CORS or cross-domain cookie config. Simpler and more secure.</a:t>
-            </a:r>
-          </a:p>
-        </p:txBody>
-      </p:sp>
-      <p:sp>
-        <p:nvSpPr>
-          <p:cNvPr id="17" name="Rounded Rectangle 16"/>
+              <a:t>Live SAP S/4HANA integration across 6 touchpoints</a:t>
+            </a:r>
+          </a:p>
+        </p:txBody>
+      </p:sp>
+      <p:sp>
+        <p:nvSpPr>
+          <p:cNvPr id="10" name="Oval 9"/>
           <p:cNvSpPr/>
           <p:nvPr/>
         </p:nvSpPr>
         <p:spPr>
           <a:xfrm>
-            <a:off x="6254496" y="2514600"/>
-            <a:ext cx="5440680" cy="1700784"/>
-          </a:xfrm>
-          <a:prstGeom prst="roundRect">
-            <a:avLst>
-              <a:gd name="adj" fmla="val 5000"/>
-            </a:avLst>
-          </a:prstGeom>
-          <a:solidFill>
-            <a:srgbClr val="FFFFFF"/>
-          </a:solidFill>
-          <a:ln w="12700">
-            <a:solidFill>
-              <a:srgbClr val="D5DDE3"/>
-            </a:solidFill>
-          </a:ln>
-          <a:effectLst/>
-        </p:spPr>
-        <p:style>
-          <a:lnRef idx="1">
-            <a:schemeClr val="accent1"/>
-          </a:lnRef>
-          <a:fillRef idx="3">
-            <a:schemeClr val="accent1"/>
-          </a:fillRef>
-          <a:effectRef idx="2">
-            <a:schemeClr val="accent1"/>
-          </a:effectRef>
-          <a:fontRef idx="minor">
-            <a:schemeClr val="lt1"/>
-          </a:fontRef>
-        </p:style>
-        <p:txBody>
-          <a:bodyPr rtlCol="0" anchor="ctr"/>
-          <a:lstStyle/>
-          <a:p>
-            <a:pPr algn="ctr"/>
-          </a:p>
-        </p:txBody>
-      </p:sp>
-      <p:sp>
-        <p:nvSpPr>
-          <p:cNvPr id="18" name="Rectangle 17"/>
-          <p:cNvSpPr/>
-          <p:nvPr/>
-        </p:nvSpPr>
-        <p:spPr>
-          <a:xfrm>
-            <a:off x="6254496" y="2514600"/>
-            <a:ext cx="5440680" cy="91440"/>
-          </a:xfrm>
-          <a:prstGeom prst="rect">
+            <a:off x="822960" y="3950208"/>
+            <a:ext cx="146304" cy="146304"/>
+          </a:xfrm>
+          <a:prstGeom prst="ellipse">
             <a:avLst/>
           </a:prstGeom>
           <a:solidFill>
@@ -23860,14 +23927,14 @@
       </p:sp>
       <p:sp>
         <p:nvSpPr>
-          <p:cNvPr id="19" name="TextBox 18"/>
+          <p:cNvPr id="11" name="TextBox 10"/>
           <p:cNvSpPr txBox="1"/>
           <p:nvPr/>
         </p:nvSpPr>
         <p:spPr>
           <a:xfrm>
-            <a:off x="6528816" y="2752344"/>
-            <a:ext cx="4983480" cy="237744"/>
+            <a:off x="1143000" y="3886200"/>
+            <a:ext cx="9601200" cy="457200"/>
           </a:xfrm>
           <a:prstGeom prst="rect">
             <a:avLst/>
@@ -23875,158 +23942,46 @@
           <a:noFill/>
         </p:spPr>
         <p:txBody>
-          <a:bodyPr wrap="square" lIns="0" rIns="0" tIns="0" bIns="0" anchor="t">
+          <a:bodyPr wrap="square" anchor="t" lIns="0" rIns="0" tIns="0" bIns="0">
             <a:spAutoFit/>
           </a:bodyPr>
           <a:lstStyle/>
           <a:p>
-            <a:pPr algn="l"/>
-            <a:r>
-              <a:rPr sz="950" b="1">
-                <a:solidFill>
-                  <a:srgbClr val="E0912F"/>
+            <a:pPr algn="l">
+              <a:lnSpc>
+                <a:spcPct val="100000"/>
+              </a:lnSpc>
+              <a:spcBef>
+                <a:spcPts val="0"/>
+              </a:spcBef>
+              <a:spcAft>
+                <a:spcPts val="400"/>
+              </a:spcAft>
+            </a:pPr>
+            <a:r>
+              <a:rPr sz="1450" b="0">
+                <a:solidFill>
+                  <a:srgbClr val="D5DEE5"/>
                 </a:solidFill>
                 <a:latin typeface="Segoe UI"/>
               </a:rPr>
-              <a:t>DATABASE</a:t>
-            </a:r>
-          </a:p>
-        </p:txBody>
-      </p:sp>
-      <p:sp>
-        <p:nvSpPr>
-          <p:cNvPr id="20" name="TextBox 19"/>
-          <p:cNvSpPr txBox="1"/>
-          <p:nvPr/>
-        </p:nvSpPr>
-        <p:spPr>
-          <a:xfrm>
-            <a:off x="6528816" y="3008376"/>
-            <a:ext cx="4983480" cy="365760"/>
-          </a:xfrm>
-          <a:prstGeom prst="rect">
-            <a:avLst/>
-          </a:prstGeom>
-          <a:noFill/>
-        </p:spPr>
-        <p:txBody>
-          <a:bodyPr wrap="square" lIns="0" rIns="0" tIns="0" bIns="0" anchor="t">
-            <a:spAutoFit/>
-          </a:bodyPr>
-          <a:lstStyle/>
-          <a:p>
-            <a:pPr algn="l"/>
-            <a:r>
-              <a:rPr sz="1500" b="1">
-                <a:solidFill>
-                  <a:srgbClr val="112A40"/>
-                </a:solidFill>
-                <a:latin typeface="Segoe UI Semibold"/>
-              </a:rPr>
-              <a:t>Managed Postgres, TLS on</a:t>
-            </a:r>
-          </a:p>
-        </p:txBody>
-      </p:sp>
-      <p:sp>
-        <p:nvSpPr>
-          <p:cNvPr id="21" name="TextBox 20"/>
-          <p:cNvSpPr txBox="1"/>
-          <p:nvPr/>
-        </p:nvSpPr>
-        <p:spPr>
-          <a:xfrm>
-            <a:off x="6528816" y="3410712"/>
-            <a:ext cx="4937760" cy="740664"/>
-          </a:xfrm>
-          <a:prstGeom prst="rect">
-            <a:avLst/>
-          </a:prstGeom>
-          <a:noFill/>
-        </p:spPr>
-        <p:txBody>
-          <a:bodyPr wrap="square" lIns="0" rIns="0" tIns="0" bIns="0" anchor="t">
-            <a:spAutoFit/>
-          </a:bodyPr>
-          <a:lstStyle/>
-          <a:p>
-            <a:pPr algn="l">
-              <a:lnSpc>
-                <a:spcPct val="108000"/>
-              </a:lnSpc>
-            </a:pPr>
-            <a:r>
-              <a:rPr sz="1050" b="0">
-                <a:solidFill>
-                  <a:srgbClr val="5A6B78"/>
-                </a:solidFill>
-                <a:latin typeface="Segoe UI"/>
-              </a:rPr>
-              <a:t>A single DATABASE_URL with automatic TLS runs on Render, Neon, Railway, Supabase or RDS — zero code change from local dev.</a:t>
-            </a:r>
-          </a:p>
-        </p:txBody>
-      </p:sp>
-      <p:sp>
-        <p:nvSpPr>
-          <p:cNvPr id="22" name="Rounded Rectangle 21"/>
+              <a:t>Role-based access with an immutable, verified audit trail</a:t>
+            </a:r>
+          </a:p>
+        </p:txBody>
+      </p:sp>
+      <p:sp>
+        <p:nvSpPr>
+          <p:cNvPr id="12" name="Oval 11"/>
           <p:cNvSpPr/>
           <p:nvPr/>
         </p:nvSpPr>
         <p:spPr>
           <a:xfrm>
-            <a:off x="502920" y="4343400"/>
-            <a:ext cx="5440680" cy="1700784"/>
-          </a:xfrm>
-          <a:prstGeom prst="roundRect">
-            <a:avLst>
-              <a:gd name="adj" fmla="val 5000"/>
-            </a:avLst>
-          </a:prstGeom>
-          <a:solidFill>
-            <a:srgbClr val="FFFFFF"/>
-          </a:solidFill>
-          <a:ln w="12700">
-            <a:solidFill>
-              <a:srgbClr val="D5DDE3"/>
-            </a:solidFill>
-          </a:ln>
-          <a:effectLst/>
-        </p:spPr>
-        <p:style>
-          <a:lnRef idx="1">
-            <a:schemeClr val="accent1"/>
-          </a:lnRef>
-          <a:fillRef idx="3">
-            <a:schemeClr val="accent1"/>
-          </a:fillRef>
-          <a:effectRef idx="2">
-            <a:schemeClr val="accent1"/>
-          </a:effectRef>
-          <a:fontRef idx="minor">
-            <a:schemeClr val="lt1"/>
-          </a:fontRef>
-        </p:style>
-        <p:txBody>
-          <a:bodyPr rtlCol="0" anchor="ctr"/>
-          <a:lstStyle/>
-          <a:p>
-            <a:pPr algn="ctr"/>
-          </a:p>
-        </p:txBody>
-      </p:sp>
-      <p:sp>
-        <p:nvSpPr>
-          <p:cNvPr id="23" name="Rectangle 22"/>
-          <p:cNvSpPr/>
-          <p:nvPr/>
-        </p:nvSpPr>
-        <p:spPr>
-          <a:xfrm>
-            <a:off x="502920" y="4343400"/>
-            <a:ext cx="5440680" cy="91440"/>
-          </a:xfrm>
-          <a:prstGeom prst="rect">
+            <a:off x="822960" y="4453128"/>
+            <a:ext cx="146304" cy="146304"/>
+          </a:xfrm>
+          <a:prstGeom prst="ellipse">
             <a:avLst/>
           </a:prstGeom>
           <a:solidFill>
@@ -24061,14 +24016,14 @@
       </p:sp>
       <p:sp>
         <p:nvSpPr>
-          <p:cNvPr id="24" name="TextBox 23"/>
+          <p:cNvPr id="13" name="TextBox 12"/>
           <p:cNvSpPr txBox="1"/>
           <p:nvPr/>
         </p:nvSpPr>
         <p:spPr>
           <a:xfrm>
-            <a:off x="777240" y="4581144"/>
-            <a:ext cx="4983480" cy="237744"/>
+            <a:off x="1143000" y="4389120"/>
+            <a:ext cx="9601200" cy="457200"/>
           </a:xfrm>
           <a:prstGeom prst="rect">
             <a:avLst/>
@@ -24076,121 +24031,53 @@
           <a:noFill/>
         </p:spPr>
         <p:txBody>
-          <a:bodyPr wrap="square" lIns="0" rIns="0" tIns="0" bIns="0" anchor="t">
+          <a:bodyPr wrap="square" anchor="t" lIns="0" rIns="0" tIns="0" bIns="0">
             <a:spAutoFit/>
           </a:bodyPr>
           <a:lstStyle/>
           <a:p>
-            <a:pPr algn="l"/>
-            <a:r>
-              <a:rPr sz="950" b="1">
-                <a:solidFill>
-                  <a:srgbClr val="E0912F"/>
+            <a:pPr algn="l">
+              <a:lnSpc>
+                <a:spcPct val="100000"/>
+              </a:lnSpc>
+              <a:spcBef>
+                <a:spcPts val="0"/>
+              </a:spcBef>
+              <a:spcAft>
+                <a:spcPts val="400"/>
+              </a:spcAft>
+            </a:pPr>
+            <a:r>
+              <a:rPr sz="1450" b="0">
+                <a:solidFill>
+                  <a:srgbClr val="D5DEE5"/>
                 </a:solidFill>
                 <a:latin typeface="Segoe UI"/>
               </a:rPr>
-              <a:t>HARDENED</a:t>
-            </a:r>
-          </a:p>
-        </p:txBody>
-      </p:sp>
-      <p:sp>
-        <p:nvSpPr>
-          <p:cNvPr id="25" name="TextBox 24"/>
-          <p:cNvSpPr txBox="1"/>
-          <p:nvPr/>
-        </p:nvSpPr>
-        <p:spPr>
-          <a:xfrm>
-            <a:off x="777240" y="4837176"/>
-            <a:ext cx="4983480" cy="365760"/>
-          </a:xfrm>
-          <a:prstGeom prst="rect">
-            <a:avLst/>
-          </a:prstGeom>
-          <a:noFill/>
-        </p:spPr>
-        <p:txBody>
-          <a:bodyPr wrap="square" lIns="0" rIns="0" tIns="0" bIns="0" anchor="t">
-            <a:spAutoFit/>
-          </a:bodyPr>
-          <a:lstStyle/>
-          <a:p>
-            <a:pPr algn="l"/>
-            <a:r>
-              <a:rPr sz="1500" b="1">
-                <a:solidFill>
-                  <a:srgbClr val="112A40"/>
-                </a:solidFill>
-                <a:latin typeface="Segoe UI Semibold"/>
-              </a:rPr>
-              <a:t>Production-ready by default</a:t>
-            </a:r>
-          </a:p>
-        </p:txBody>
-      </p:sp>
-      <p:sp>
-        <p:nvSpPr>
-          <p:cNvPr id="26" name="TextBox 25"/>
-          <p:cNvSpPr txBox="1"/>
-          <p:nvPr/>
-        </p:nvSpPr>
-        <p:spPr>
-          <a:xfrm>
-            <a:off x="777240" y="5239512"/>
-            <a:ext cx="4937760" cy="740664"/>
-          </a:xfrm>
-          <a:prstGeom prst="rect">
-            <a:avLst/>
-          </a:prstGeom>
-          <a:noFill/>
-        </p:spPr>
-        <p:txBody>
-          <a:bodyPr wrap="square" lIns="0" rIns="0" tIns="0" bIns="0" anchor="t">
-            <a:spAutoFit/>
-          </a:bodyPr>
-          <a:lstStyle/>
-          <a:p>
-            <a:pPr algn="l">
-              <a:lnSpc>
-                <a:spcPct val="108000"/>
-              </a:lnSpc>
-            </a:pPr>
-            <a:r>
-              <a:rPr sz="1050" b="0">
-                <a:solidFill>
-                  <a:srgbClr val="5A6B78"/>
-                </a:solidFill>
-                <a:latin typeface="Segoe UI"/>
-              </a:rPr>
-              <a:t>Secure cookies, HSTS, HTTPS-only, a boot check that refuses a weak JWT secret, and one-time rotation of every seeded password.</a:t>
-            </a:r>
-          </a:p>
-        </p:txBody>
-      </p:sp>
-      <p:sp>
-        <p:nvSpPr>
-          <p:cNvPr id="27" name="Rounded Rectangle 26"/>
+              <a:t>Verified end-to-end — 32 tests plus a live run to closure</a:t>
+            </a:r>
+          </a:p>
+        </p:txBody>
+      </p:sp>
+      <p:sp>
+        <p:nvSpPr>
+          <p:cNvPr id="14" name="Rectangle 13"/>
           <p:cNvSpPr/>
           <p:nvPr/>
         </p:nvSpPr>
         <p:spPr>
           <a:xfrm>
-            <a:off x="6254496" y="4343400"/>
-            <a:ext cx="5440680" cy="1700784"/>
-          </a:xfrm>
-          <a:prstGeom prst="roundRect">
-            <a:avLst>
-              <a:gd name="adj" fmla="val 5000"/>
-            </a:avLst>
+            <a:off x="822960" y="5257800"/>
+            <a:ext cx="3840480" cy="18288"/>
+          </a:xfrm>
+          <a:prstGeom prst="rect">
+            <a:avLst/>
           </a:prstGeom>
           <a:solidFill>
-            <a:srgbClr val="FFFFFF"/>
+            <a:srgbClr val="3A5369"/>
           </a:solidFill>
-          <a:ln w="12700">
-            <a:solidFill>
-              <a:srgbClr val="D5DDE3"/>
-            </a:solidFill>
+          <a:ln>
+            <a:noFill/>
           </a:ln>
           <a:effectLst/>
         </p:spPr>
@@ -24218,20 +24105,87 @@
       </p:sp>
       <p:sp>
         <p:nvSpPr>
-          <p:cNvPr id="28" name="Rectangle 27"/>
+          <p:cNvPr id="15" name="TextBox 14"/>
+          <p:cNvSpPr txBox="1"/>
+          <p:nvPr/>
+        </p:nvSpPr>
+        <p:spPr>
+          <a:xfrm>
+            <a:off x="822960" y="5486400"/>
+            <a:ext cx="10058400" cy="914400"/>
+          </a:xfrm>
+          <a:prstGeom prst="rect">
+            <a:avLst/>
+          </a:prstGeom>
+          <a:noFill/>
+        </p:spPr>
+        <p:txBody>
+          <a:bodyPr wrap="square" anchor="t" lIns="0" rIns="0" tIns="0" bIns="0">
+            <a:spAutoFit/>
+          </a:bodyPr>
+          <a:lstStyle/>
+          <a:p>
+            <a:pPr algn="l">
+              <a:lnSpc>
+                <a:spcPct val="100000"/>
+              </a:lnSpc>
+              <a:spcBef>
+                <a:spcPts val="0"/>
+              </a:spcBef>
+              <a:spcAft>
+                <a:spcPts val="400"/>
+              </a:spcAft>
+            </a:pPr>
+            <a:r>
+              <a:rPr sz="2200" b="1">
+                <a:solidFill>
+                  <a:srgbClr val="FFFFFF"/>
+                </a:solidFill>
+                <a:latin typeface="Segoe UI Semibold"/>
+              </a:rPr>
+              <a:t>Thank you</a:t>
+            </a:r>
+          </a:p>
+          <a:p>
+            <a:pPr algn="l">
+              <a:lnSpc>
+                <a:spcPct val="100000"/>
+              </a:lnSpc>
+              <a:spcBef>
+                <a:spcPts val="0"/>
+              </a:spcBef>
+              <a:spcAft>
+                <a:spcPts val="400"/>
+              </a:spcAft>
+            </a:pPr>
+            <a:r>
+              <a:rPr sz="1250" b="0">
+                <a:solidFill>
+                  <a:srgbClr val="B9C7D2"/>
+                </a:solidFill>
+                <a:latin typeface="Segoe UI"/>
+              </a:rPr>
+              <a:t>Keshav Raj Jain   ·   Orient Paper &amp; Mill — CCMS</a:t>
+            </a:r>
+          </a:p>
+        </p:txBody>
+      </p:sp>
+      <p:sp>
+        <p:nvSpPr>
+          <p:cNvPr id="16" name="Rectangle 15"/>
           <p:cNvSpPr/>
           <p:nvPr/>
         </p:nvSpPr>
         <p:spPr>
           <a:xfrm>
-            <a:off x="6254496" y="4343400"/>
-            <a:ext cx="5440680" cy="91440"/>
+            <a:off x="9509760" y="0"/>
+            <a:ext cx="2681935" cy="6858000"/>
           </a:xfrm>
           <a:prstGeom prst="rect">
             <a:avLst/>
           </a:prstGeom>
           <a:solidFill>
-            <a:srgbClr val="E0912F"/>
+            <a:srgbClr val="1B3A55"/>
           </a:solidFill>
           <a:ln>
             <a:noFill/>
@@ -24262,14 +24216,58 @@
       </p:sp>
       <p:sp>
         <p:nvSpPr>
-          <p:cNvPr id="29" name="TextBox 28"/>
+          <p:cNvPr id="17" name="Rectangle 16"/>
+          <p:cNvSpPr/>
+          <p:nvPr/>
+        </p:nvSpPr>
+        <p:spPr>
+          <a:xfrm>
+            <a:off x="9509760" y="0"/>
+            <a:ext cx="54864" cy="6858000"/>
+          </a:xfrm>
+          <a:prstGeom prst="rect">
+            <a:avLst/>
+          </a:prstGeom>
+          <a:solidFill>
+            <a:srgbClr val="1F8A80"/>
+          </a:solidFill>
+          <a:ln>
+            <a:noFill/>
+          </a:ln>
+          <a:effectLst/>
+        </p:spPr>
+        <p:style>
+          <a:lnRef idx="1">
+            <a:schemeClr val="accent1"/>
+          </a:lnRef>
+          <a:fillRef idx="3">
+            <a:schemeClr val="accent1"/>
+          </a:fillRef>
+          <a:effectRef idx="2">
+            <a:schemeClr val="accent1"/>
+          </a:effectRef>
+          <a:fontRef idx="minor">
+            <a:schemeClr val="lt1"/>
+          </a:fontRef>
+        </p:style>
+        <p:txBody>
+          <a:bodyPr rtlCol="0" anchor="ctr"/>
+          <a:lstStyle/>
+          <a:p>
+            <a:pPr algn="ctr"/>
+          </a:p>
+        </p:txBody>
+      </p:sp>
+      <p:sp>
+        <p:nvSpPr>
+          <p:cNvPr id="18" name="TextBox 17"/>
           <p:cNvSpPr txBox="1"/>
           <p:nvPr/>
         </p:nvSpPr>
         <p:spPr>
           <a:xfrm>
-            <a:off x="6528816" y="4581144"/>
-            <a:ext cx="4983480" cy="237744"/>
+            <a:off x="9829800" y="2286000"/>
+            <a:ext cx="2194560" cy="2286000"/>
           </a:xfrm>
           <a:prstGeom prst="rect">
             <a:avLst/>
@@ -24277,94 +24275,96 @@
           <a:noFill/>
         </p:spPr>
         <p:txBody>
-          <a:bodyPr wrap="square" lIns="0" rIns="0" tIns="0" bIns="0" anchor="t">
+          <a:bodyPr wrap="square" anchor="ctr" lIns="0" rIns="0" tIns="0" bIns="0">
             <a:spAutoFit/>
           </a:bodyPr>
           <a:lstStyle/>
           <a:p>
-            <a:pPr algn="l"/>
-            <a:r>
-              <a:rPr sz="950" b="1">
+            <a:pPr algn="l">
+              <a:lnSpc>
+                <a:spcPct val="100000"/>
+              </a:lnSpc>
+              <a:spcBef>
+                <a:spcPts val="0"/>
+              </a:spcBef>
+              <a:spcAft>
+                <a:spcPts val="200"/>
+              </a:spcAft>
+            </a:pPr>
+            <a:r>
+              <a:rPr sz="3000" b="1">
+                <a:solidFill>
+                  <a:srgbClr val="FFFFFF"/>
+                </a:solidFill>
+                <a:latin typeface="Segoe UI Semibold"/>
+              </a:rPr>
+              <a:t>Q &amp; A</a:t>
+            </a:r>
+          </a:p>
+          <a:p>
+            <a:pPr algn="l">
+              <a:lnSpc>
+                <a:spcPct val="100000"/>
+              </a:lnSpc>
+              <a:spcBef>
+                <a:spcPts val="0"/>
+              </a:spcBef>
+              <a:spcAft>
+                <a:spcPts val="200"/>
+              </a:spcAft>
+            </a:pPr>
+            <a:r>
+              <a:rPr sz="1000" b="0">
+                <a:solidFill>
+                  <a:srgbClr val="FFFFFF"/>
+                </a:solidFill>
+                <a:latin typeface="Segoe UI"/>
+              </a:rPr>
+              <a:t> </a:t>
+            </a:r>
+          </a:p>
+          <a:p>
+            <a:pPr algn="l">
+              <a:lnSpc>
+                <a:spcPct val="100000"/>
+              </a:lnSpc>
+              <a:spcBef>
+                <a:spcPts val="0"/>
+              </a:spcBef>
+              <a:spcAft>
+                <a:spcPts val="200"/>
+              </a:spcAft>
+            </a:pPr>
+            <a:r>
+              <a:rPr sz="1300" b="1">
                 <a:solidFill>
                   <a:srgbClr val="E0912F"/>
                 </a:solidFill>
                 <a:latin typeface="Segoe UI"/>
               </a:rPr>
-              <a:t>EMAIL</a:t>
-            </a:r>
-          </a:p>
-        </p:txBody>
-      </p:sp>
-      <p:sp>
-        <p:nvSpPr>
-          <p:cNvPr id="30" name="TextBox 29"/>
-          <p:cNvSpPr txBox="1"/>
-          <p:nvPr/>
-        </p:nvSpPr>
-        <p:spPr>
-          <a:xfrm>
-            <a:off x="6528816" y="4837176"/>
-            <a:ext cx="4983480" cy="365760"/>
-          </a:xfrm>
-          <a:prstGeom prst="rect">
-            <a:avLst/>
-          </a:prstGeom>
-          <a:noFill/>
-        </p:spPr>
-        <p:txBody>
-          <a:bodyPr wrap="square" lIns="0" rIns="0" tIns="0" bIns="0" anchor="t">
-            <a:spAutoFit/>
-          </a:bodyPr>
-          <a:lstStyle/>
-          <a:p>
-            <a:pPr algn="l"/>
-            <a:r>
-              <a:rPr sz="1500" b="1">
-                <a:solidFill>
-                  <a:srgbClr val="112A40"/>
-                </a:solidFill>
-                <a:latin typeface="Segoe UI Semibold"/>
-              </a:rPr>
-              <a:t>Real inbox delivery</a:t>
-            </a:r>
-          </a:p>
-        </p:txBody>
-      </p:sp>
-      <p:sp>
-        <p:nvSpPr>
-          <p:cNvPr id="31" name="TextBox 30"/>
-          <p:cNvSpPr txBox="1"/>
-          <p:nvPr/>
-        </p:nvSpPr>
-        <p:spPr>
-          <a:xfrm>
-            <a:off x="6528816" y="5239512"/>
-            <a:ext cx="4937760" cy="740664"/>
-          </a:xfrm>
-          <a:prstGeom prst="rect">
-            <a:avLst/>
-          </a:prstGeom>
-          <a:noFill/>
-        </p:spPr>
-        <p:txBody>
-          <a:bodyPr wrap="square" lIns="0" rIns="0" tIns="0" bIns="0" anchor="t">
-            <a:spAutoFit/>
-          </a:bodyPr>
-          <a:lstStyle/>
+              <a:t>Questions</a:t>
+            </a:r>
+          </a:p>
           <a:p>
             <a:pPr algn="l">
               <a:lnSpc>
-                <a:spcPct val="108000"/>
-              </a:lnSpc>
-            </a:pPr>
-            <a:r>
-              <a:rPr sz="1050" b="0">
-                <a:solidFill>
-                  <a:srgbClr val="5A6B78"/>
+                <a:spcPct val="100000"/>
+              </a:lnSpc>
+              <a:spcBef>
+                <a:spcPts val="0"/>
+              </a:spcBef>
+              <a:spcAft>
+                <a:spcPts val="200"/>
+              </a:spcAft>
+            </a:pPr>
+            <a:r>
+              <a:rPr sz="1300" b="1">
+                <a:solidFill>
+                  <a:srgbClr val="E0912F"/>
                 </a:solidFill>
                 <a:latin typeface="Segoe UI"/>
               </a:rPr>
-              <a:t>Customer and staff notifications go out over SMTP (Gmail / Brevo / any relay) and are mirrored to the in-app Emails trail.</a:t>
+              <a:t>welcome</a:t>
             </a:r>
           </a:p>
         </p:txBody>
@@ -28143,7 +28143,7 @@
         <p:spPr>
           <a:xfrm>
             <a:off x="502920" y="3840480"/>
-            <a:ext cx="11192256" cy="960120"/>
+            <a:ext cx="11192256" cy="1243584"/>
           </a:xfrm>
           <a:prstGeom prst="roundRect">
             <a:avLst/>
@@ -28959,7 +28959,7 @@
         </p:nvSpPr>
         <p:spPr>
           <a:xfrm>
-            <a:off x="502920" y="5029200"/>
+            <a:off x="502920" y="5212080"/>
             <a:ext cx="11155680" cy="1280160"/>
           </a:xfrm>
           <a:prstGeom prst="rect">

</xml_diff>